<commit_message>
Apresentação: prévia do portal (cliente cota só com código) e slide de vendas online
Co-Authored-By: Claude Opus 5.5 <noreply@anthropic.com>
Claude-Session: https://claude.ai/code/session_01AHZHvPsx9zvMYGTsdyQVMz
</commit_message>
<xml_diff>
--- a/docs/apresentacao/PartsFlow-apresentacao-curta.pptx
+++ b/docs/apresentacao/PartsFlow-apresentacao-curta.pptx
@@ -13,9 +13,11 @@
     <p:sldId id="261" r:id="rId7"/>
     <p:sldId id="262" r:id="rId8"/>
     <p:sldId id="263" r:id="rId9"/>
+    <p:sldId id="264" r:id="rId10"/>
+    <p:sldId id="265" r:id="rId11"/>
   </p:sldIdLst>
   <p:notesMasterIdLst>
-    <p:notesMasterId r:id="rId10"/>
+    <p:notesMasterId r:id="rId12"/>
   </p:notesMasterIdLst>
   <p:sldSz cx="12192000" cy="6858000"/>
   <p:notesSz cx="6858000" cy="12192000"/>
@@ -114,32 +116,34 @@
   <p:extLst>
     <p:ext uri="{521415D9-36F7-43E2-AB2F-B90AF26B5E84}">
       <p14:sectionLst xmlns:p14="http://schemas.microsoft.com/office/powerpoint/2010/main">
-        <p14:section name="O ganho" id="{84801a51-b860-24ba-9c06-e3ccbe987a91}">
+        <p14:section name="O ganho" id="{0f7d58f8-16b0-ce21-c291-b76ea330f170}">
           <p14:sldIdLst>
             <p14:sldId id="256"/>
             <p14:sldId id="257"/>
           </p14:sldIdLst>
         </p14:section>
-        <p14:section name="A cotação" id="{f1740997-b36e-499b-0e9a-8f630f18e350}">
+        <p14:section name="A cotação" id="{552ac0e8-5e94-f40d-c9af-3988d3e94fef}">
           <p14:sldIdLst>
             <p14:sldId id="258"/>
             <p14:sldId id="259"/>
           </p14:sldIdLst>
         </p14:section>
-        <p14:section name="A carteira" id="{8fc60e47-7eda-1b30-1812-66e82ed6e6bb}">
+        <p14:section name="A carteira" id="{a849ae14-2a98-3af3-68ab-29febccaee8d}">
           <p14:sldIdLst>
             <p14:sldId id="260"/>
             <p14:sldId id="261"/>
-          </p14:sldIdLst>
-        </p14:section>
-        <p14:section name="Futuro" id="{e7ef207e-2d53-3c6a-bc92-988a899f3f1d}">
-          <p14:sldIdLst>
             <p14:sldId id="262"/>
           </p14:sldIdLst>
         </p14:section>
-        <p14:section name="Proposta" id="{19d21df5-93f4-5ab4-6024-c0ddd2a6641d}">
+        <p14:section name="Futuro" id="{69917ba7-9d11-2594-62f4-9f239f71806f}">
           <p14:sldIdLst>
             <p14:sldId id="263"/>
+            <p14:sldId id="264"/>
+          </p14:sldIdLst>
+        </p14:section>
+        <p14:section name="Proposta" id="{23fd055b-c34b-87c7-4545-2e108ba8048f}">
+          <p14:sldIdLst>
+            <p14:sldId id="265"/>
           </p14:sldIdLst>
         </p14:section>
       </p14:sectionLst>
@@ -588,6 +592,94 @@
 </p:notes>
 </file>
 
+<file path=ppt/notesSlides/notesSlide10.xml><?xml version="1.0" encoding="utf-8"?>
+<p:notes xmlns:a="http://schemas.openxmlformats.org/drawingml/2006/main" xmlns:r="http://schemas.openxmlformats.org/officeDocument/2006/relationships" xmlns:p="http://schemas.openxmlformats.org/presentationml/2006/main">
+  <p:cSld>
+    <p:spTree>
+      <p:nvGrpSpPr>
+        <p:cNvPr id="1" name=""/>
+        <p:cNvGrpSpPr/>
+        <p:nvPr/>
+      </p:nvGrpSpPr>
+      <p:grpSpPr>
+        <a:xfrm>
+          <a:off x="0" y="0"/>
+          <a:ext cx="0" cy="0"/>
+          <a:chOff x="0" y="0"/>
+          <a:chExt cx="0" cy="0"/>
+        </a:xfrm>
+      </p:grpSpPr>
+      <p:sp>
+        <p:nvSpPr>
+          <p:cNvPr id="2" name="Slide Image Placeholder 1"/>
+          <p:cNvSpPr>
+            <a:spLocks noGrp="1" noRot="1" noChangeAspect="1"/>
+          </p:cNvSpPr>
+          <p:nvPr>
+            <p:ph type="sldImg"/>
+          </p:nvPr>
+        </p:nvSpPr>
+        <p:spPr/>
+      </p:sp>
+      <p:sp>
+        <p:nvSpPr>
+          <p:cNvPr id="3" name="Notes Placeholder 2"/>
+          <p:cNvSpPr>
+            <a:spLocks noGrp="1"/>
+          </p:cNvSpPr>
+          <p:nvPr>
+            <p:ph type="body" idx="1"/>
+          </p:nvPr>
+        </p:nvSpPr>
+        <p:spPr/>
+        <p:txBody>
+          <a:bodyPr/>
+          <a:lstStyle/>
+          <a:p>
+            <a:r>
+              <a:rPr lang="en-US" dirty="0"/>
+              <a:t>Pedir pouco e com saída fácil. Pergunta fechada no final: posso começar com [nome] e [nome] na segunda?</a:t>
+            </a:r>
+            <a:endParaRPr lang="en-US" dirty="0"/>
+          </a:p>
+        </p:txBody>
+      </p:sp>
+      <p:sp>
+        <p:nvSpPr>
+          <p:cNvPr id="4" name="Slide Number Placeholder 3"/>
+          <p:cNvSpPr>
+            <a:spLocks noGrp="1"/>
+          </p:cNvSpPr>
+          <p:nvPr>
+            <p:ph type="sldNum" sz="quarter" idx="10"/>
+          </p:nvPr>
+        </p:nvSpPr>
+        <p:spPr/>
+        <p:txBody>
+          <a:bodyPr/>
+          <a:lstStyle/>
+          <a:p>
+            <a:fld id="{F7021451-1387-4CA6-816F-3879F97B5CBC}" type="slidenum">
+              <a:rPr lang="en-US"/>
+              <a:t>10</a:t>
+            </a:fld>
+            <a:endParaRPr lang="en-US"/>
+          </a:p>
+        </p:txBody>
+      </p:sp>
+    </p:spTree>
+    <p:extLst>
+      <p:ext uri="{BB962C8B-B14F-4D97-AF65-F5344CB8AC3E}">
+        <p14:creationId xmlns:p14="http://schemas.microsoft.com/office/powerpoint/2010/main" val="1024086991"/>
+      </p:ext>
+    </p:extLst>
+  </p:cSld>
+  <p:clrMapOvr>
+    <a:masterClrMapping/>
+  </p:clrMapOvr>
+</p:notes>
+</file>
+
 <file path=ppt/notesSlides/notesSlide2.xml><?xml version="1.0" encoding="utf-8"?>
 <p:notes xmlns:a="http://schemas.openxmlformats.org/drawingml/2006/main" xmlns:r="http://schemas.openxmlformats.org/officeDocument/2006/relationships" xmlns:p="http://schemas.openxmlformats.org/presentationml/2006/main">
   <p:cSld>
@@ -1074,7 +1166,7 @@
           <a:p>
             <a:r>
               <a:rPr lang="en-US" dirty="0"/>
-              <a:t>Não prometer data: mostrar que o caminho existe. Começa ao lado do JBoss, sem risco. Com o tempo, integra: o saldo e os pedidos do ERP entram sozinhos, o cadastro alimenta o site e o Vendas On, e os avisos vão pelo WhatsApp oficial.</a:t>
+              <a:t>Deixar claro que é PRÉVIA, o próximo passo. O cliente entra com login, digita o código que ele tem (de qualquer marca, o sistema converte) e a quantidade, ou cola a lista. Vê na hora disponibilidade e preço da tabela dele. O que é pequeno e tem saldo sai sozinho; o resto chega pronto pro vendedor, com nota de prioridade. O vendedor para de digitar cotação e vai cuidar da carteira.</a:t>
             </a:r>
             <a:endParaRPr lang="en-US" dirty="0"/>
           </a:p>
@@ -1162,7 +1254,7 @@
           <a:p>
             <a:r>
               <a:rPr lang="en-US" dirty="0"/>
-              <a:t>Pedir pouco e com saída fácil. Pergunta fechada no final: posso começar com [nome] e [nome] na segunda?</a:t>
+              <a:t>Não prometer data: mostrar que o caminho existe. Começa ao lado do JBoss, sem risco. Com o tempo, integra: o saldo e os pedidos do ERP entram sozinhos, o cadastro alimenta o site e o Vendas On, e os avisos vão pelo WhatsApp oficial.</a:t>
             </a:r>
             <a:endParaRPr lang="en-US" dirty="0"/>
           </a:p>
@@ -1186,6 +1278,94 @@
             <a:fld id="{F7021451-1387-4CA6-816F-3879F97B5CBC}" type="slidenum">
               <a:rPr lang="en-US"/>
               <a:t>8</a:t>
+            </a:fld>
+            <a:endParaRPr lang="en-US"/>
+          </a:p>
+        </p:txBody>
+      </p:sp>
+    </p:spTree>
+    <p:extLst>
+      <p:ext uri="{BB962C8B-B14F-4D97-AF65-F5344CB8AC3E}">
+        <p14:creationId xmlns:p14="http://schemas.microsoft.com/office/powerpoint/2010/main" val="1024086991"/>
+      </p:ext>
+    </p:extLst>
+  </p:cSld>
+  <p:clrMapOvr>
+    <a:masterClrMapping/>
+  </p:clrMapOvr>
+</p:notes>
+</file>
+
+<file path=ppt/notesSlides/notesSlide9.xml><?xml version="1.0" encoding="utf-8"?>
+<p:notes xmlns:a="http://schemas.openxmlformats.org/drawingml/2006/main" xmlns:r="http://schemas.openxmlformats.org/officeDocument/2006/relationships" xmlns:p="http://schemas.openxmlformats.org/presentationml/2006/main">
+  <p:cSld>
+    <p:spTree>
+      <p:nvGrpSpPr>
+        <p:cNvPr id="1" name=""/>
+        <p:cNvGrpSpPr/>
+        <p:nvPr/>
+      </p:nvGrpSpPr>
+      <p:grpSpPr>
+        <a:xfrm>
+          <a:off x="0" y="0"/>
+          <a:ext cx="0" cy="0"/>
+          <a:chOff x="0" y="0"/>
+          <a:chExt cx="0" cy="0"/>
+        </a:xfrm>
+      </p:grpSpPr>
+      <p:sp>
+        <p:nvSpPr>
+          <p:cNvPr id="2" name="Slide Image Placeholder 1"/>
+          <p:cNvSpPr>
+            <a:spLocks noGrp="1" noRot="1" noChangeAspect="1"/>
+          </p:cNvSpPr>
+          <p:nvPr>
+            <p:ph type="sldImg"/>
+          </p:nvPr>
+        </p:nvSpPr>
+        <p:spPr/>
+      </p:sp>
+      <p:sp>
+        <p:nvSpPr>
+          <p:cNvPr id="3" name="Notes Placeholder 2"/>
+          <p:cNvSpPr>
+            <a:spLocks noGrp="1"/>
+          </p:cNvSpPr>
+          <p:nvPr>
+            <p:ph type="body" idx="1"/>
+          </p:nvPr>
+        </p:nvSpPr>
+        <p:spPr/>
+        <p:txBody>
+          <a:bodyPr/>
+          <a:lstStyle/>
+          <a:p>
+            <a:r>
+              <a:rPr lang="en-US" dirty="0"/>
+              <a:t>O trabalho mais pesado do e-commerce de autopeça é o cadastro: descrição, foto e compatibilidade. Isso o PartsFlow já tem. Caminho mais simples: um integrador (hub de marketplace, ex. Bling, Tiny, ANYMARKET) que já fala com Mercado Livre, Shopee e loja virtual; o PartsFlow manda cadastro, saldo e preço pro hub, e os pedidos voltam. Caminho mais completo: API direta do Mercado Livre e da Shopee. Em qualquer um, um só cadastro e um só estoque.</a:t>
+            </a:r>
+            <a:endParaRPr lang="en-US" dirty="0"/>
+          </a:p>
+        </p:txBody>
+      </p:sp>
+      <p:sp>
+        <p:nvSpPr>
+          <p:cNvPr id="4" name="Slide Number Placeholder 3"/>
+          <p:cNvSpPr>
+            <a:spLocks noGrp="1"/>
+          </p:cNvSpPr>
+          <p:nvPr>
+            <p:ph type="sldNum" sz="quarter" idx="10"/>
+          </p:nvPr>
+        </p:nvSpPr>
+        <p:spPr/>
+        <p:txBody>
+          <a:bodyPr/>
+          <a:lstStyle/>
+          <a:p>
+            <a:fld id="{F7021451-1387-4CA6-816F-3879F97B5CBC}" type="slidenum">
+              <a:rPr lang="en-US"/>
+              <a:t>9</a:t>
             </a:fld>
             <a:endParaRPr lang="en-US"/>
           </a:p>
@@ -2313,6 +2493,121 @@
 </p:sld>
 </file>
 
+<file path=ppt/slides/slide10.xml><?xml version="1.0" encoding="utf-8"?>
+<p:sld xmlns:a="http://schemas.openxmlformats.org/drawingml/2006/main" xmlns:r="http://schemas.openxmlformats.org/officeDocument/2006/relationships" xmlns:p="http://schemas.openxmlformats.org/presentationml/2006/main">
+  <p:cSld name="Slide 10">
+    <p:spTree>
+      <p:nvGrpSpPr>
+        <p:cNvPr id="1" name=""/>
+        <p:cNvGrpSpPr/>
+        <p:nvPr/>
+      </p:nvGrpSpPr>
+      <p:grpSpPr>
+        <a:xfrm>
+          <a:off x="0" y="0"/>
+          <a:ext cx="0" cy="0"/>
+          <a:chOff x="0" y="0"/>
+          <a:chExt cx="0" cy="0"/>
+        </a:xfrm>
+      </p:grpSpPr>
+      <p:sp>
+        <p:nvSpPr>
+          <p:cNvPr id="2" name="Text 0"/>
+          <p:cNvSpPr/>
+          <p:nvPr>
+            <p:ph idx="100" type="title" hasCustomPrompt="1"/>
+          </p:nvPr>
+        </p:nvSpPr>
+        <p:spPr>
+          <a:xfrm>
+            <a:off x="731520" y="1828800"/>
+            <a:ext cx="10607040" cy="2103120"/>
+          </a:xfrm>
+          <a:prstGeom prst="rect">
+            <a:avLst/>
+          </a:prstGeom>
+          <a:noFill/>
+          <a:ln/>
+        </p:spPr>
+        <p:txBody>
+          <a:bodyPr wrap="square" lIns="0" tIns="0" rIns="0" bIns="0" rtlCol="0" anchor="t"/>
+          <a:lstStyle/>
+          <a:p>
+            <a:pPr algn="l" indent="0" marL="0">
+              <a:buNone/>
+            </a:pPr>
+            <a:r>
+              <a:rPr lang="en-US" sz="5200" b="1" dirty="0">
+                <a:solidFill>
+                  <a:schemeClr val="accent4"/>
+                </a:solidFill>
+              </a:rPr>
+              <a:t>Piloto de 30 dias.</a:t>
+            </a:r>
+            <a:endParaRPr lang="en-US" sz="5200" dirty="0"/>
+          </a:p>
+          <a:p>
+            <a:pPr algn="l" indent="0" marL="0">
+              <a:buNone/>
+            </a:pPr>
+            <a:r>
+              <a:rPr lang="en-US" sz="5200" b="1" dirty="0">
+                <a:solidFill>
+                  <a:schemeClr val="accent2"/>
+                </a:solidFill>
+              </a:rPr>
+              <a:t>Sem mexer no ERP.</a:t>
+            </a:r>
+            <a:endParaRPr lang="en-US" sz="5200" dirty="0"/>
+          </a:p>
+        </p:txBody>
+      </p:sp>
+      <p:sp>
+        <p:nvSpPr>
+          <p:cNvPr id="3" name="Text 0"/>
+          <p:cNvSpPr/>
+          <p:nvPr>
+            <p:ph idx="101" type="body" hasCustomPrompt="1"/>
+          </p:nvPr>
+        </p:nvSpPr>
+        <p:spPr>
+          <a:xfrm>
+            <a:off x="731520" y="4160520"/>
+            <a:ext cx="9692640" cy="1188720"/>
+          </a:xfrm>
+          <a:prstGeom prst="rect">
+            <a:avLst/>
+          </a:prstGeom>
+          <a:noFill/>
+          <a:ln/>
+        </p:spPr>
+        <p:txBody>
+          <a:bodyPr wrap="square" lIns="0" tIns="0" rIns="0" bIns="0" rtlCol="0" anchor="t"/>
+          <a:lstStyle/>
+          <a:p>
+            <a:pPr algn="l" indent="0" marL="0">
+              <a:buNone/>
+            </a:pPr>
+            <a:r>
+              <a:rPr lang="en-US" sz="2200" dirty="0">
+                <a:solidFill>
+                  <a:schemeClr val="accent6"/>
+                </a:solidFill>
+              </a:rPr>
+              <a:t>[2] vendedores · medimos tempo de cotação de motor, cotações por dia e quantas viram pedido. Se não melhorar, paramos.</a:t>
+            </a:r>
+            <a:endParaRPr lang="en-US" sz="2200" dirty="0"/>
+          </a:p>
+        </p:txBody>
+      </p:sp>
+    </p:spTree>
+  </p:cSld>
+  <p:clrMapOvr>
+    <a:masterClrMapping/>
+  </p:clrMapOvr>
+</p:sld>
+</file>
+
 <file path=ppt/slides/slide2.xml><?xml version="1.0" encoding="utf-8"?>
 <p:sld xmlns:a="http://schemas.openxmlformats.org/drawingml/2006/main" xmlns:r="http://schemas.openxmlformats.org/officeDocument/2006/relationships" xmlns:p="http://schemas.openxmlformats.org/presentationml/2006/main">
   <p:cSld name="Slide 2">
@@ -6553,7 +6848,7 @@
                   <a:schemeClr val="accent1"/>
                 </a:solidFill>
               </a:rPr>
-              <a:t>DAQUI PRA FRENTE</a:t>
+              <a:t>PRÓXIMO PASSO · PRÉVIA</a:t>
             </a:r>
             <a:endParaRPr lang="en-US" sz="1400" dirty="0"/>
           </a:p>
@@ -6591,7 +6886,7 @@
                   <a:schemeClr val="tx1"/>
                 </a:solidFill>
               </a:rPr>
-              <a:t>Hoje ao lado do JBoss. Amanhã, integrado.</a:t>
+              <a:t>O cliente cota sozinho, só com o código e a quantidade</a:t>
             </a:r>
             <a:endParaRPr lang="en-US" sz="3000" dirty="0"/>
           </a:p>
@@ -6599,89 +6894,26 @@
       </p:sp>
       <p:sp>
         <p:nvSpPr>
-          <p:cNvPr id="4" name="PartsFlow"/>
+          <p:cNvPr id="4" name="Fundo da prévia"/>
           <p:cNvSpPr/>
           <p:nvPr/>
         </p:nvSpPr>
         <p:spPr>
           <a:xfrm>
-            <a:off x="4727448" y="3246120"/>
-            <a:ext cx="2743200" cy="1097280"/>
+            <a:off x="457200" y="1600200"/>
+            <a:ext cx="11247120" cy="4343400"/>
           </a:xfrm>
           <a:prstGeom prst="roundRect">
             <a:avLst>
-              <a:gd name="adj" fmla="val 12500"/>
+              <a:gd name="adj" fmla="val 2526"/>
             </a:avLst>
           </a:prstGeom>
           <a:solidFill>
-            <a:srgbClr val="13294B"/>
+            <a:srgbClr val="FFFFFF"/>
           </a:solidFill>
           <a:ln w="12700">
             <a:solidFill>
-              <a:srgbClr val="13294B"/>
-            </a:solidFill>
-            <a:prstDash val="solid"/>
-          </a:ln>
-        </p:spPr>
-      </p:sp>
-      <p:sp>
-        <p:nvSpPr>
-          <p:cNvPr id="5" name="Text 3"/>
-          <p:cNvSpPr txBox="1"/>
-          <p:nvPr/>
-        </p:nvSpPr>
-        <p:spPr>
-          <a:xfrm>
-            <a:off x="4727448" y="3246120"/>
-            <a:ext cx="2743200" cy="1097280"/>
-          </a:xfrm>
-          <a:prstGeom prst="rect">
-            <a:avLst/>
-          </a:prstGeom>
-          <a:noFill/>
-          <a:ln/>
-        </p:spPr>
-        <p:txBody>
-          <a:bodyPr wrap="square" lIns="0" tIns="0" rIns="0" bIns="0" rtlCol="0" anchor="ctr"/>
-          <a:lstStyle/>
-          <a:p>
-            <a:pPr algn="ctr" indent="0" marL="0">
-              <a:buNone/>
-            </a:pPr>
-            <a:r>
-              <a:rPr lang="en-US" sz="2600" b="1" dirty="0">
-                <a:solidFill>
-                  <a:srgbClr val="F4F1EA"/>
-                </a:solidFill>
-              </a:rPr>
-              <a:t>PartsFlow</a:t>
-            </a:r>
-            <a:endParaRPr lang="en-US" sz="2600" dirty="0"/>
-          </a:p>
-        </p:txBody>
-      </p:sp>
-      <p:sp>
-        <p:nvSpPr>
-          <p:cNvPr id="6" name="Cartão"/>
-          <p:cNvSpPr/>
-          <p:nvPr/>
-        </p:nvSpPr>
-        <p:spPr>
-          <a:xfrm>
-            <a:off x="548640" y="1783080"/>
-            <a:ext cx="3108960" cy="1325880"/>
-          </a:xfrm>
-          <a:prstGeom prst="roundRect">
-            <a:avLst>
-              <a:gd name="adj" fmla="val 8276"/>
-            </a:avLst>
-          </a:prstGeom>
-          <a:solidFill>
-            <a:srgbClr val="E9EEF5"/>
-          </a:solidFill>
-          <a:ln w="12700">
-            <a:solidFill>
-              <a:srgbClr val="E9EEF5"/>
+              <a:srgbClr val="FFFFFF"/>
             </a:solidFill>
             <a:prstDash val="solid"/>
           </a:ln>
@@ -6694,16 +6926,39 @@
           </a:effectLst>
         </p:spPr>
       </p:sp>
-      <p:sp>
-        <p:nvSpPr>
-          <p:cNvPr id="7" name="Text 5"/>
+      <p:pic>
+        <p:nvPicPr>
+          <p:cNvPr id="5" name="Captura" descr="Prévia do portal: o cliente digita código e quantidade; o vendedor recebe a cotação pronta">    </p:cNvPr>
+          <p:cNvPicPr>
+            <a:picLocks noChangeAspect="1"/>
+          </p:cNvPicPr>
+          <p:nvPr/>
+        </p:nvPicPr>
+        <p:blipFill>
+          <a:blip r:embed="rId1"/>
+          <a:srcRect l="0" r="0" t="0" b="0"/>
+          <a:stretch/>
+        </p:blipFill>
+        <p:spPr>
+          <a:xfrm>
+            <a:off x="548640" y="1673352"/>
+            <a:ext cx="11064240" cy="4160520"/>
+          </a:xfrm>
+          <a:prstGeom prst="rect">
+            <a:avLst/>
+          </a:prstGeom>
+        </p:spPr>
+      </p:pic>
+      <p:sp>
+        <p:nvSpPr>
+          <p:cNvPr id="6" name="Text 3"/>
           <p:cNvSpPr txBox="1"/>
           <p:nvPr/>
         </p:nvSpPr>
         <p:spPr>
           <a:xfrm>
-            <a:off x="777240" y="1920240"/>
-            <a:ext cx="2651760" cy="1051560"/>
+            <a:off x="548640" y="5989320"/>
+            <a:ext cx="11064240" cy="365760"/>
           </a:xfrm>
           <a:prstGeom prst="rect">
             <a:avLst/>
@@ -6719,406 +6974,12 @@
               <a:buNone/>
             </a:pPr>
             <a:r>
-              <a:rPr lang="en-US" sz="1800" b="1" dirty="0">
-                <a:solidFill>
-                  <a:srgbClr val="13294B"/>
-                </a:solidFill>
-              </a:rPr>
-              <a:t>JBoss / ERP</a:t>
-            </a:r>
-            <a:endParaRPr lang="en-US" sz="1800" dirty="0"/>
-          </a:p>
-          <a:p>
-            <a:pPr indent="0" marL="0">
-              <a:buNone/>
-            </a:pPr>
-            <a:r>
-              <a:rPr lang="en-US" sz="1400" dirty="0">
+              <a:rPr lang="en-US" sz="1400" i="1" dirty="0">
                 <a:solidFill>
                   <a:srgbClr val="3E4F66"/>
                 </a:solidFill>
               </a:rPr>
-              <a:t>Saldo, pedidos e preço entrando sozinhos</a:t>
-            </a:r>
-            <a:endParaRPr lang="en-US" sz="1800" dirty="0"/>
-          </a:p>
-        </p:txBody>
-      </p:sp>
-      <p:sp>
-        <p:nvSpPr>
-          <p:cNvPr id="8" name="Ligação"/>
-          <p:cNvSpPr/>
-          <p:nvPr/>
-        </p:nvSpPr>
-        <p:spPr>
-          <a:xfrm>
-            <a:off x="3657600" y="3108960"/>
-            <a:ext cx="1069848" cy="137160"/>
-          </a:xfrm>
-          <a:prstGeom prst="line">
-            <a:avLst/>
-          </a:prstGeom>
-          <a:noFill/>
-          <a:ln w="25400">
-            <a:solidFill>
-              <a:srgbClr val="C2591F"/>
-            </a:solidFill>
-            <a:prstDash val="dash"/>
-          </a:ln>
-        </p:spPr>
-      </p:sp>
-      <p:sp>
-        <p:nvSpPr>
-          <p:cNvPr id="9" name="Cartão"/>
-          <p:cNvSpPr/>
-          <p:nvPr/>
-        </p:nvSpPr>
-        <p:spPr>
-          <a:xfrm>
-            <a:off x="8549640" y="1783080"/>
-            <a:ext cx="3108960" cy="1325880"/>
-          </a:xfrm>
-          <a:prstGeom prst="roundRect">
-            <a:avLst>
-              <a:gd name="adj" fmla="val 8276"/>
-            </a:avLst>
-          </a:prstGeom>
-          <a:solidFill>
-            <a:srgbClr val="E9EEF5"/>
-          </a:solidFill>
-          <a:ln w="12700">
-            <a:solidFill>
-              <a:srgbClr val="E9EEF5"/>
-            </a:solidFill>
-            <a:prstDash val="solid"/>
-          </a:ln>
-          <a:effectLst>
-            <a:outerShdw sx="100000" sy="100000" kx="0" ky="0" algn="bl" rotWithShape="0" blurRad="76200" dist="25400" dir="5400000">
-              <a:srgbClr val="000000">
-                <a:alpha val="10000"/>
-              </a:srgbClr>
-            </a:outerShdw>
-          </a:effectLst>
-        </p:spPr>
-      </p:sp>
-      <p:sp>
-        <p:nvSpPr>
-          <p:cNvPr id="10" name="Text 8"/>
-          <p:cNvSpPr txBox="1"/>
-          <p:nvPr/>
-        </p:nvSpPr>
-        <p:spPr>
-          <a:xfrm>
-            <a:off x="8778240" y="1920240"/>
-            <a:ext cx="2651760" cy="1051560"/>
-          </a:xfrm>
-          <a:prstGeom prst="rect">
-            <a:avLst/>
-          </a:prstGeom>
-          <a:noFill/>
-          <a:ln/>
-        </p:spPr>
-        <p:txBody>
-          <a:bodyPr wrap="square" lIns="0" tIns="0" rIns="0" bIns="0" rtlCol="0" anchor="ctr"/>
-          <a:lstStyle/>
-          <a:p>
-            <a:pPr indent="0" marL="0">
-              <a:buNone/>
-            </a:pPr>
-            <a:r>
-              <a:rPr lang="en-US" sz="1800" b="1" dirty="0">
-                <a:solidFill>
-                  <a:srgbClr val="13294B"/>
-                </a:solidFill>
-              </a:rPr>
-              <a:t>Nosso site de vendas</a:t>
-            </a:r>
-            <a:endParaRPr lang="en-US" sz="1800" dirty="0"/>
-          </a:p>
-          <a:p>
-            <a:pPr indent="0" marL="0">
-              <a:buNone/>
-            </a:pPr>
-            <a:r>
-              <a:rPr lang="en-US" sz="1400" dirty="0">
-                <a:solidFill>
-                  <a:srgbClr val="3E4F66"/>
-                </a:solidFill>
-              </a:rPr>
-              <a:t>Mesmo cadastro, aplicação e foto</a:t>
-            </a:r>
-            <a:endParaRPr lang="en-US" sz="1800" dirty="0"/>
-          </a:p>
-        </p:txBody>
-      </p:sp>
-      <p:sp>
-        <p:nvSpPr>
-          <p:cNvPr id="11" name="Ligação"/>
-          <p:cNvSpPr/>
-          <p:nvPr/>
-        </p:nvSpPr>
-        <p:spPr>
-          <a:xfrm flipV="1">
-            <a:off x="7470648" y="3108960"/>
-            <a:ext cx="1078992" cy="137160"/>
-          </a:xfrm>
-          <a:prstGeom prst="line">
-            <a:avLst/>
-          </a:prstGeom>
-          <a:noFill/>
-          <a:ln w="25400">
-            <a:solidFill>
-              <a:srgbClr val="C2591F"/>
-            </a:solidFill>
-            <a:prstDash val="dash"/>
-          </a:ln>
-        </p:spPr>
-      </p:sp>
-      <p:sp>
-        <p:nvSpPr>
-          <p:cNvPr id="12" name="Cartão"/>
-          <p:cNvSpPr/>
-          <p:nvPr/>
-        </p:nvSpPr>
-        <p:spPr>
-          <a:xfrm>
-            <a:off x="548640" y="4572000"/>
-            <a:ext cx="3108960" cy="1325880"/>
-          </a:xfrm>
-          <a:prstGeom prst="roundRect">
-            <a:avLst>
-              <a:gd name="adj" fmla="val 8276"/>
-            </a:avLst>
-          </a:prstGeom>
-          <a:solidFill>
-            <a:srgbClr val="E9EEF5"/>
-          </a:solidFill>
-          <a:ln w="12700">
-            <a:solidFill>
-              <a:srgbClr val="E9EEF5"/>
-            </a:solidFill>
-            <a:prstDash val="solid"/>
-          </a:ln>
-          <a:effectLst>
-            <a:outerShdw sx="100000" sy="100000" kx="0" ky="0" algn="bl" rotWithShape="0" blurRad="76200" dist="25400" dir="5400000">
-              <a:srgbClr val="000000">
-                <a:alpha val="10000"/>
-              </a:srgbClr>
-            </a:outerShdw>
-          </a:effectLst>
-        </p:spPr>
-      </p:sp>
-      <p:sp>
-        <p:nvSpPr>
-          <p:cNvPr id="13" name="Text 11"/>
-          <p:cNvSpPr txBox="1"/>
-          <p:nvPr/>
-        </p:nvSpPr>
-        <p:spPr>
-          <a:xfrm>
-            <a:off x="777240" y="4709160"/>
-            <a:ext cx="2651760" cy="1051560"/>
-          </a:xfrm>
-          <a:prstGeom prst="rect">
-            <a:avLst/>
-          </a:prstGeom>
-          <a:noFill/>
-          <a:ln/>
-        </p:spPr>
-        <p:txBody>
-          <a:bodyPr wrap="square" lIns="0" tIns="0" rIns="0" bIns="0" rtlCol="0" anchor="ctr"/>
-          <a:lstStyle/>
-          <a:p>
-            <a:pPr indent="0" marL="0">
-              <a:buNone/>
-            </a:pPr>
-            <a:r>
-              <a:rPr lang="en-US" sz="1800" b="1" dirty="0">
-                <a:solidFill>
-                  <a:srgbClr val="13294B"/>
-                </a:solidFill>
-              </a:rPr>
-              <a:t>Vendas On e marketplaces</a:t>
-            </a:r>
-            <a:endParaRPr lang="en-US" sz="1800" dirty="0"/>
-          </a:p>
-          <a:p>
-            <a:pPr indent="0" marL="0">
-              <a:buNone/>
-            </a:pPr>
-            <a:r>
-              <a:rPr lang="en-US" sz="1400" dirty="0">
-                <a:solidFill>
-                  <a:srgbClr val="3E4F66"/>
-                </a:solidFill>
-              </a:rPr>
-              <a:t>Anúncio e pedido sem redigitar</a:t>
-            </a:r>
-            <a:endParaRPr lang="en-US" sz="1800" dirty="0"/>
-          </a:p>
-        </p:txBody>
-      </p:sp>
-      <p:sp>
-        <p:nvSpPr>
-          <p:cNvPr id="14" name="Ligação"/>
-          <p:cNvSpPr/>
-          <p:nvPr/>
-        </p:nvSpPr>
-        <p:spPr>
-          <a:xfrm flipV="1">
-            <a:off x="3657600" y="4343400"/>
-            <a:ext cx="1069848" cy="228600"/>
-          </a:xfrm>
-          <a:prstGeom prst="line">
-            <a:avLst/>
-          </a:prstGeom>
-          <a:noFill/>
-          <a:ln w="25400">
-            <a:solidFill>
-              <a:srgbClr val="C2591F"/>
-            </a:solidFill>
-            <a:prstDash val="dash"/>
-          </a:ln>
-        </p:spPr>
-      </p:sp>
-      <p:sp>
-        <p:nvSpPr>
-          <p:cNvPr id="15" name="Cartão"/>
-          <p:cNvSpPr/>
-          <p:nvPr/>
-        </p:nvSpPr>
-        <p:spPr>
-          <a:xfrm>
-            <a:off x="8549640" y="4572000"/>
-            <a:ext cx="3108960" cy="1325880"/>
-          </a:xfrm>
-          <a:prstGeom prst="roundRect">
-            <a:avLst>
-              <a:gd name="adj" fmla="val 8276"/>
-            </a:avLst>
-          </a:prstGeom>
-          <a:solidFill>
-            <a:srgbClr val="E9EEF5"/>
-          </a:solidFill>
-          <a:ln w="12700">
-            <a:solidFill>
-              <a:srgbClr val="E9EEF5"/>
-            </a:solidFill>
-            <a:prstDash val="solid"/>
-          </a:ln>
-          <a:effectLst>
-            <a:outerShdw sx="100000" sy="100000" kx="0" ky="0" algn="bl" rotWithShape="0" blurRad="76200" dist="25400" dir="5400000">
-              <a:srgbClr val="000000">
-                <a:alpha val="10000"/>
-              </a:srgbClr>
-            </a:outerShdw>
-          </a:effectLst>
-        </p:spPr>
-      </p:sp>
-      <p:sp>
-        <p:nvSpPr>
-          <p:cNvPr id="16" name="Text 14"/>
-          <p:cNvSpPr txBox="1"/>
-          <p:nvPr/>
-        </p:nvSpPr>
-        <p:spPr>
-          <a:xfrm>
-            <a:off x="8778240" y="4709160"/>
-            <a:ext cx="2651760" cy="1051560"/>
-          </a:xfrm>
-          <a:prstGeom prst="rect">
-            <a:avLst/>
-          </a:prstGeom>
-          <a:noFill/>
-          <a:ln/>
-        </p:spPr>
-        <p:txBody>
-          <a:bodyPr wrap="square" lIns="0" tIns="0" rIns="0" bIns="0" rtlCol="0" anchor="ctr"/>
-          <a:lstStyle/>
-          <a:p>
-            <a:pPr indent="0" marL="0">
-              <a:buNone/>
-            </a:pPr>
-            <a:r>
-              <a:rPr lang="en-US" sz="1800" b="1" dirty="0">
-                <a:solidFill>
-                  <a:srgbClr val="13294B"/>
-                </a:solidFill>
-              </a:rPr>
-              <a:t>WhatsApp oficial</a:t>
-            </a:r>
-            <a:endParaRPr lang="en-US" sz="1800" dirty="0"/>
-          </a:p>
-          <a:p>
-            <a:pPr indent="0" marL="0">
-              <a:buNone/>
-            </a:pPr>
-            <a:r>
-              <a:rPr lang="en-US" sz="1400" dirty="0">
-                <a:solidFill>
-                  <a:srgbClr val="3E4F66"/>
-                </a:solidFill>
-              </a:rPr>
-              <a:t>Avisar pedido emitido e faturado</a:t>
-            </a:r>
-            <a:endParaRPr lang="en-US" sz="1800" dirty="0"/>
-          </a:p>
-        </p:txBody>
-      </p:sp>
-      <p:sp>
-        <p:nvSpPr>
-          <p:cNvPr id="17" name="Ligação"/>
-          <p:cNvSpPr/>
-          <p:nvPr/>
-        </p:nvSpPr>
-        <p:spPr>
-          <a:xfrm>
-            <a:off x="7470648" y="4343400"/>
-            <a:ext cx="1078992" cy="228600"/>
-          </a:xfrm>
-          <a:prstGeom prst="line">
-            <a:avLst/>
-          </a:prstGeom>
-          <a:noFill/>
-          <a:ln w="25400">
-            <a:solidFill>
-              <a:srgbClr val="C2591F"/>
-            </a:solidFill>
-            <a:prstDash val="dash"/>
-          </a:ln>
-        </p:spPr>
-      </p:sp>
-      <p:sp>
-        <p:nvSpPr>
-          <p:cNvPr id="18" name="Text 16"/>
-          <p:cNvSpPr txBox="1"/>
-          <p:nvPr/>
-        </p:nvSpPr>
-        <p:spPr>
-          <a:xfrm>
-            <a:off x="548640" y="5989320"/>
-            <a:ext cx="11064240" cy="365760"/>
-          </a:xfrm>
-          <a:prstGeom prst="rect">
-            <a:avLst/>
-          </a:prstGeom>
-          <a:noFill/>
-          <a:ln/>
-        </p:spPr>
-        <p:txBody>
-          <a:bodyPr wrap="square" lIns="0" tIns="0" rIns="0" bIns="0" rtlCol="0" anchor="ctr"/>
-          <a:lstStyle/>
-          <a:p>
-            <a:pPr indent="0" marL="0">
-              <a:buNone/>
-            </a:pPr>
-            <a:r>
-              <a:rPr lang="en-US" sz="1400" i="1" dirty="0">
-                <a:solidFill>
-                  <a:srgbClr val="3E4F66"/>
-                </a:solidFill>
-              </a:rPr>
-              <a:t>Portal do cliente (próximo passo): com login, ele cota sozinho digitando só código e quantidade.</a:t>
+              <a:t>Código de qualquer marca (Spicer, REI, Stahl, original) · preço da tabela dele · o que não sair sozinho vai pro vendedor</a:t>
             </a:r>
             <a:endParaRPr lang="en-US" sz="1400" dirty="0"/>
           </a:p>
@@ -7196,7 +7057,43 @@
       </p:grpSpPr>
       <p:sp>
         <p:nvSpPr>
-          <p:cNvPr id="2" name="Text 0"/>
+          <p:cNvPr id="2" name="Chamada"/>
+          <p:cNvSpPr txBox="1"/>
+          <p:nvPr/>
+        </p:nvSpPr>
+        <p:spPr>
+          <a:xfrm>
+            <a:off x="548640" y="365760"/>
+            <a:ext cx="8229600" cy="365760"/>
+          </a:xfrm>
+          <a:prstGeom prst="rect">
+            <a:avLst/>
+          </a:prstGeom>
+          <a:noFill/>
+          <a:ln/>
+        </p:spPr>
+        <p:txBody>
+          <a:bodyPr wrap="square" lIns="0" tIns="0" rIns="0" bIns="0" rtlCol="0" anchor="ctr"/>
+          <a:lstStyle/>
+          <a:p>
+            <a:pPr indent="0" marL="0">
+              <a:buNone/>
+            </a:pPr>
+            <a:r>
+              <a:rPr lang="en-US" sz="1400" b="1" spc="300" kern="0" dirty="0">
+                <a:solidFill>
+                  <a:schemeClr val="accent1"/>
+                </a:solidFill>
+              </a:rPr>
+              <a:t>DAQUI PRA FRENTE</a:t>
+            </a:r>
+            <a:endParaRPr lang="en-US" sz="1400" dirty="0"/>
+          </a:p>
+        </p:txBody>
+      </p:sp>
+      <p:sp>
+        <p:nvSpPr>
+          <p:cNvPr id="3" name="Text 0"/>
           <p:cNvSpPr/>
           <p:nvPr>
             <p:ph idx="100" type="title" hasCustomPrompt="1"/>
@@ -7204,8 +7101,8 @@
         </p:nvSpPr>
         <p:spPr>
           <a:xfrm>
-            <a:off x="731520" y="1828800"/>
-            <a:ext cx="10607040" cy="2103120"/>
+            <a:off x="548640" y="777240"/>
+            <a:ext cx="11064240" cy="822960"/>
           </a:xfrm>
           <a:prstGeom prst="rect">
             <a:avLst/>
@@ -7221,28 +7118,647 @@
               <a:buNone/>
             </a:pPr>
             <a:r>
-              <a:rPr lang="en-US" sz="5200" b="1" dirty="0">
-                <a:solidFill>
-                  <a:schemeClr val="accent4"/>
-                </a:solidFill>
-              </a:rPr>
-              <a:t>Piloto de 30 dias.</a:t>
-            </a:r>
-            <a:endParaRPr lang="en-US" sz="5200" dirty="0"/>
-          </a:p>
-          <a:p>
-            <a:pPr algn="l" indent="0" marL="0">
+              <a:rPr lang="en-US" sz="3000" b="1" dirty="0">
+                <a:solidFill>
+                  <a:schemeClr val="tx1"/>
+                </a:solidFill>
+              </a:rPr>
+              <a:t>Hoje ao lado do JBoss. Amanhã, integrado.</a:t>
+            </a:r>
+            <a:endParaRPr lang="en-US" sz="3000" dirty="0"/>
+          </a:p>
+        </p:txBody>
+      </p:sp>
+      <p:sp>
+        <p:nvSpPr>
+          <p:cNvPr id="4" name="PartsFlow"/>
+          <p:cNvSpPr/>
+          <p:nvPr/>
+        </p:nvSpPr>
+        <p:spPr>
+          <a:xfrm>
+            <a:off x="4727448" y="3246120"/>
+            <a:ext cx="2743200" cy="1097280"/>
+          </a:xfrm>
+          <a:prstGeom prst="roundRect">
+            <a:avLst>
+              <a:gd name="adj" fmla="val 12500"/>
+            </a:avLst>
+          </a:prstGeom>
+          <a:solidFill>
+            <a:srgbClr val="13294B"/>
+          </a:solidFill>
+          <a:ln w="12700">
+            <a:solidFill>
+              <a:srgbClr val="13294B"/>
+            </a:solidFill>
+            <a:prstDash val="solid"/>
+          </a:ln>
+        </p:spPr>
+      </p:sp>
+      <p:sp>
+        <p:nvSpPr>
+          <p:cNvPr id="5" name="Text 3"/>
+          <p:cNvSpPr txBox="1"/>
+          <p:nvPr/>
+        </p:nvSpPr>
+        <p:spPr>
+          <a:xfrm>
+            <a:off x="4727448" y="3246120"/>
+            <a:ext cx="2743200" cy="1097280"/>
+          </a:xfrm>
+          <a:prstGeom prst="rect">
+            <a:avLst/>
+          </a:prstGeom>
+          <a:noFill/>
+          <a:ln/>
+        </p:spPr>
+        <p:txBody>
+          <a:bodyPr wrap="square" lIns="0" tIns="0" rIns="0" bIns="0" rtlCol="0" anchor="ctr"/>
+          <a:lstStyle/>
+          <a:p>
+            <a:pPr algn="ctr" indent="0" marL="0">
               <a:buNone/>
             </a:pPr>
             <a:r>
-              <a:rPr lang="en-US" sz="5200" b="1" dirty="0">
-                <a:solidFill>
-                  <a:schemeClr val="accent2"/>
-                </a:solidFill>
-              </a:rPr>
-              <a:t>Sem mexer no ERP.</a:t>
-            </a:r>
-            <a:endParaRPr lang="en-US" sz="5200" dirty="0"/>
+              <a:rPr lang="en-US" sz="2600" b="1" dirty="0">
+                <a:solidFill>
+                  <a:srgbClr val="F4F1EA"/>
+                </a:solidFill>
+              </a:rPr>
+              <a:t>PartsFlow</a:t>
+            </a:r>
+            <a:endParaRPr lang="en-US" sz="2600" dirty="0"/>
+          </a:p>
+        </p:txBody>
+      </p:sp>
+      <p:sp>
+        <p:nvSpPr>
+          <p:cNvPr id="6" name="Cartão"/>
+          <p:cNvSpPr/>
+          <p:nvPr/>
+        </p:nvSpPr>
+        <p:spPr>
+          <a:xfrm>
+            <a:off x="548640" y="1783080"/>
+            <a:ext cx="3108960" cy="1325880"/>
+          </a:xfrm>
+          <a:prstGeom prst="roundRect">
+            <a:avLst>
+              <a:gd name="adj" fmla="val 8276"/>
+            </a:avLst>
+          </a:prstGeom>
+          <a:solidFill>
+            <a:srgbClr val="E9EEF5"/>
+          </a:solidFill>
+          <a:ln w="12700">
+            <a:solidFill>
+              <a:srgbClr val="E9EEF5"/>
+            </a:solidFill>
+            <a:prstDash val="solid"/>
+          </a:ln>
+          <a:effectLst>
+            <a:outerShdw sx="100000" sy="100000" kx="0" ky="0" algn="bl" rotWithShape="0" blurRad="76200" dist="25400" dir="5400000">
+              <a:srgbClr val="000000">
+                <a:alpha val="10000"/>
+              </a:srgbClr>
+            </a:outerShdw>
+          </a:effectLst>
+        </p:spPr>
+      </p:sp>
+      <p:sp>
+        <p:nvSpPr>
+          <p:cNvPr id="7" name="Text 5"/>
+          <p:cNvSpPr txBox="1"/>
+          <p:nvPr/>
+        </p:nvSpPr>
+        <p:spPr>
+          <a:xfrm>
+            <a:off x="777240" y="1920240"/>
+            <a:ext cx="2651760" cy="1051560"/>
+          </a:xfrm>
+          <a:prstGeom prst="rect">
+            <a:avLst/>
+          </a:prstGeom>
+          <a:noFill/>
+          <a:ln/>
+        </p:spPr>
+        <p:txBody>
+          <a:bodyPr wrap="square" lIns="0" tIns="0" rIns="0" bIns="0" rtlCol="0" anchor="ctr"/>
+          <a:lstStyle/>
+          <a:p>
+            <a:pPr indent="0" marL="0">
+              <a:buNone/>
+            </a:pPr>
+            <a:r>
+              <a:rPr lang="en-US" sz="1800" b="1" dirty="0">
+                <a:solidFill>
+                  <a:srgbClr val="13294B"/>
+                </a:solidFill>
+              </a:rPr>
+              <a:t>JBoss / ERP</a:t>
+            </a:r>
+            <a:endParaRPr lang="en-US" sz="1800" dirty="0"/>
+          </a:p>
+          <a:p>
+            <a:pPr indent="0" marL="0">
+              <a:buNone/>
+            </a:pPr>
+            <a:r>
+              <a:rPr lang="en-US" sz="1400" dirty="0">
+                <a:solidFill>
+                  <a:srgbClr val="3E4F66"/>
+                </a:solidFill>
+              </a:rPr>
+              <a:t>Saldo, pedidos e preço entrando sozinhos</a:t>
+            </a:r>
+            <a:endParaRPr lang="en-US" sz="1800" dirty="0"/>
+          </a:p>
+        </p:txBody>
+      </p:sp>
+      <p:sp>
+        <p:nvSpPr>
+          <p:cNvPr id="8" name="Ligação"/>
+          <p:cNvSpPr/>
+          <p:nvPr/>
+        </p:nvSpPr>
+        <p:spPr>
+          <a:xfrm>
+            <a:off x="3657600" y="3108960"/>
+            <a:ext cx="1069848" cy="137160"/>
+          </a:xfrm>
+          <a:prstGeom prst="line">
+            <a:avLst/>
+          </a:prstGeom>
+          <a:noFill/>
+          <a:ln w="25400">
+            <a:solidFill>
+              <a:srgbClr val="C2591F"/>
+            </a:solidFill>
+            <a:prstDash val="dash"/>
+          </a:ln>
+        </p:spPr>
+      </p:sp>
+      <p:sp>
+        <p:nvSpPr>
+          <p:cNvPr id="9" name="Cartão"/>
+          <p:cNvSpPr/>
+          <p:nvPr/>
+        </p:nvSpPr>
+        <p:spPr>
+          <a:xfrm>
+            <a:off x="8549640" y="1783080"/>
+            <a:ext cx="3108960" cy="1325880"/>
+          </a:xfrm>
+          <a:prstGeom prst="roundRect">
+            <a:avLst>
+              <a:gd name="adj" fmla="val 8276"/>
+            </a:avLst>
+          </a:prstGeom>
+          <a:solidFill>
+            <a:srgbClr val="E9EEF5"/>
+          </a:solidFill>
+          <a:ln w="12700">
+            <a:solidFill>
+              <a:srgbClr val="E9EEF5"/>
+            </a:solidFill>
+            <a:prstDash val="solid"/>
+          </a:ln>
+          <a:effectLst>
+            <a:outerShdw sx="100000" sy="100000" kx="0" ky="0" algn="bl" rotWithShape="0" blurRad="76200" dist="25400" dir="5400000">
+              <a:srgbClr val="000000">
+                <a:alpha val="10000"/>
+              </a:srgbClr>
+            </a:outerShdw>
+          </a:effectLst>
+        </p:spPr>
+      </p:sp>
+      <p:sp>
+        <p:nvSpPr>
+          <p:cNvPr id="10" name="Text 8"/>
+          <p:cNvSpPr txBox="1"/>
+          <p:nvPr/>
+        </p:nvSpPr>
+        <p:spPr>
+          <a:xfrm>
+            <a:off x="8778240" y="1920240"/>
+            <a:ext cx="2651760" cy="1051560"/>
+          </a:xfrm>
+          <a:prstGeom prst="rect">
+            <a:avLst/>
+          </a:prstGeom>
+          <a:noFill/>
+          <a:ln/>
+        </p:spPr>
+        <p:txBody>
+          <a:bodyPr wrap="square" lIns="0" tIns="0" rIns="0" bIns="0" rtlCol="0" anchor="ctr"/>
+          <a:lstStyle/>
+          <a:p>
+            <a:pPr indent="0" marL="0">
+              <a:buNone/>
+            </a:pPr>
+            <a:r>
+              <a:rPr lang="en-US" sz="1800" b="1" dirty="0">
+                <a:solidFill>
+                  <a:srgbClr val="13294B"/>
+                </a:solidFill>
+              </a:rPr>
+              <a:t>Nosso site de vendas</a:t>
+            </a:r>
+            <a:endParaRPr lang="en-US" sz="1800" dirty="0"/>
+          </a:p>
+          <a:p>
+            <a:pPr indent="0" marL="0">
+              <a:buNone/>
+            </a:pPr>
+            <a:r>
+              <a:rPr lang="en-US" sz="1400" dirty="0">
+                <a:solidFill>
+                  <a:srgbClr val="3E4F66"/>
+                </a:solidFill>
+              </a:rPr>
+              <a:t>Mesmo cadastro, aplicação e foto</a:t>
+            </a:r>
+            <a:endParaRPr lang="en-US" sz="1800" dirty="0"/>
+          </a:p>
+        </p:txBody>
+      </p:sp>
+      <p:sp>
+        <p:nvSpPr>
+          <p:cNvPr id="11" name="Ligação"/>
+          <p:cNvSpPr/>
+          <p:nvPr/>
+        </p:nvSpPr>
+        <p:spPr>
+          <a:xfrm flipV="1">
+            <a:off x="7470648" y="3108960"/>
+            <a:ext cx="1078992" cy="137160"/>
+          </a:xfrm>
+          <a:prstGeom prst="line">
+            <a:avLst/>
+          </a:prstGeom>
+          <a:noFill/>
+          <a:ln w="25400">
+            <a:solidFill>
+              <a:srgbClr val="C2591F"/>
+            </a:solidFill>
+            <a:prstDash val="dash"/>
+          </a:ln>
+        </p:spPr>
+      </p:sp>
+      <p:sp>
+        <p:nvSpPr>
+          <p:cNvPr id="12" name="Cartão"/>
+          <p:cNvSpPr/>
+          <p:nvPr/>
+        </p:nvSpPr>
+        <p:spPr>
+          <a:xfrm>
+            <a:off x="548640" y="4572000"/>
+            <a:ext cx="3108960" cy="1325880"/>
+          </a:xfrm>
+          <a:prstGeom prst="roundRect">
+            <a:avLst>
+              <a:gd name="adj" fmla="val 8276"/>
+            </a:avLst>
+          </a:prstGeom>
+          <a:solidFill>
+            <a:srgbClr val="E9EEF5"/>
+          </a:solidFill>
+          <a:ln w="12700">
+            <a:solidFill>
+              <a:srgbClr val="E9EEF5"/>
+            </a:solidFill>
+            <a:prstDash val="solid"/>
+          </a:ln>
+          <a:effectLst>
+            <a:outerShdw sx="100000" sy="100000" kx="0" ky="0" algn="bl" rotWithShape="0" blurRad="76200" dist="25400" dir="5400000">
+              <a:srgbClr val="000000">
+                <a:alpha val="10000"/>
+              </a:srgbClr>
+            </a:outerShdw>
+          </a:effectLst>
+        </p:spPr>
+      </p:sp>
+      <p:sp>
+        <p:nvSpPr>
+          <p:cNvPr id="13" name="Text 11"/>
+          <p:cNvSpPr txBox="1"/>
+          <p:nvPr/>
+        </p:nvSpPr>
+        <p:spPr>
+          <a:xfrm>
+            <a:off x="777240" y="4709160"/>
+            <a:ext cx="2651760" cy="1051560"/>
+          </a:xfrm>
+          <a:prstGeom prst="rect">
+            <a:avLst/>
+          </a:prstGeom>
+          <a:noFill/>
+          <a:ln/>
+        </p:spPr>
+        <p:txBody>
+          <a:bodyPr wrap="square" lIns="0" tIns="0" rIns="0" bIns="0" rtlCol="0" anchor="ctr"/>
+          <a:lstStyle/>
+          <a:p>
+            <a:pPr indent="0" marL="0">
+              <a:buNone/>
+            </a:pPr>
+            <a:r>
+              <a:rPr lang="en-US" sz="1800" b="1" dirty="0">
+                <a:solidFill>
+                  <a:srgbClr val="13294B"/>
+                </a:solidFill>
+              </a:rPr>
+              <a:t>Vendas On e marketplaces</a:t>
+            </a:r>
+            <a:endParaRPr lang="en-US" sz="1800" dirty="0"/>
+          </a:p>
+          <a:p>
+            <a:pPr indent="0" marL="0">
+              <a:buNone/>
+            </a:pPr>
+            <a:r>
+              <a:rPr lang="en-US" sz="1400" dirty="0">
+                <a:solidFill>
+                  <a:srgbClr val="3E4F66"/>
+                </a:solidFill>
+              </a:rPr>
+              <a:t>Anúncio e pedido sem redigitar</a:t>
+            </a:r>
+            <a:endParaRPr lang="en-US" sz="1800" dirty="0"/>
+          </a:p>
+        </p:txBody>
+      </p:sp>
+      <p:sp>
+        <p:nvSpPr>
+          <p:cNvPr id="14" name="Ligação"/>
+          <p:cNvSpPr/>
+          <p:nvPr/>
+        </p:nvSpPr>
+        <p:spPr>
+          <a:xfrm flipV="1">
+            <a:off x="3657600" y="4343400"/>
+            <a:ext cx="1069848" cy="228600"/>
+          </a:xfrm>
+          <a:prstGeom prst="line">
+            <a:avLst/>
+          </a:prstGeom>
+          <a:noFill/>
+          <a:ln w="25400">
+            <a:solidFill>
+              <a:srgbClr val="C2591F"/>
+            </a:solidFill>
+            <a:prstDash val="dash"/>
+          </a:ln>
+        </p:spPr>
+      </p:sp>
+      <p:sp>
+        <p:nvSpPr>
+          <p:cNvPr id="15" name="Cartão"/>
+          <p:cNvSpPr/>
+          <p:nvPr/>
+        </p:nvSpPr>
+        <p:spPr>
+          <a:xfrm>
+            <a:off x="8549640" y="4572000"/>
+            <a:ext cx="3108960" cy="1325880"/>
+          </a:xfrm>
+          <a:prstGeom prst="roundRect">
+            <a:avLst>
+              <a:gd name="adj" fmla="val 8276"/>
+            </a:avLst>
+          </a:prstGeom>
+          <a:solidFill>
+            <a:srgbClr val="E9EEF5"/>
+          </a:solidFill>
+          <a:ln w="12700">
+            <a:solidFill>
+              <a:srgbClr val="E9EEF5"/>
+            </a:solidFill>
+            <a:prstDash val="solid"/>
+          </a:ln>
+          <a:effectLst>
+            <a:outerShdw sx="100000" sy="100000" kx="0" ky="0" algn="bl" rotWithShape="0" blurRad="76200" dist="25400" dir="5400000">
+              <a:srgbClr val="000000">
+                <a:alpha val="10000"/>
+              </a:srgbClr>
+            </a:outerShdw>
+          </a:effectLst>
+        </p:spPr>
+      </p:sp>
+      <p:sp>
+        <p:nvSpPr>
+          <p:cNvPr id="16" name="Text 14"/>
+          <p:cNvSpPr txBox="1"/>
+          <p:nvPr/>
+        </p:nvSpPr>
+        <p:spPr>
+          <a:xfrm>
+            <a:off x="8778240" y="4709160"/>
+            <a:ext cx="2651760" cy="1051560"/>
+          </a:xfrm>
+          <a:prstGeom prst="rect">
+            <a:avLst/>
+          </a:prstGeom>
+          <a:noFill/>
+          <a:ln/>
+        </p:spPr>
+        <p:txBody>
+          <a:bodyPr wrap="square" lIns="0" tIns="0" rIns="0" bIns="0" rtlCol="0" anchor="ctr"/>
+          <a:lstStyle/>
+          <a:p>
+            <a:pPr indent="0" marL="0">
+              <a:buNone/>
+            </a:pPr>
+            <a:r>
+              <a:rPr lang="en-US" sz="1800" b="1" dirty="0">
+                <a:solidFill>
+                  <a:srgbClr val="13294B"/>
+                </a:solidFill>
+              </a:rPr>
+              <a:t>WhatsApp oficial</a:t>
+            </a:r>
+            <a:endParaRPr lang="en-US" sz="1800" dirty="0"/>
+          </a:p>
+          <a:p>
+            <a:pPr indent="0" marL="0">
+              <a:buNone/>
+            </a:pPr>
+            <a:r>
+              <a:rPr lang="en-US" sz="1400" dirty="0">
+                <a:solidFill>
+                  <a:srgbClr val="3E4F66"/>
+                </a:solidFill>
+              </a:rPr>
+              <a:t>Avisar pedido emitido e faturado</a:t>
+            </a:r>
+            <a:endParaRPr lang="en-US" sz="1800" dirty="0"/>
+          </a:p>
+        </p:txBody>
+      </p:sp>
+      <p:sp>
+        <p:nvSpPr>
+          <p:cNvPr id="17" name="Ligação"/>
+          <p:cNvSpPr/>
+          <p:nvPr/>
+        </p:nvSpPr>
+        <p:spPr>
+          <a:xfrm>
+            <a:off x="7470648" y="4343400"/>
+            <a:ext cx="1078992" cy="228600"/>
+          </a:xfrm>
+          <a:prstGeom prst="line">
+            <a:avLst/>
+          </a:prstGeom>
+          <a:noFill/>
+          <a:ln w="25400">
+            <a:solidFill>
+              <a:srgbClr val="C2591F"/>
+            </a:solidFill>
+            <a:prstDash val="dash"/>
+          </a:ln>
+        </p:spPr>
+      </p:sp>
+      <p:sp>
+        <p:nvSpPr>
+          <p:cNvPr id="18" name="Text 16"/>
+          <p:cNvSpPr txBox="1"/>
+          <p:nvPr/>
+        </p:nvSpPr>
+        <p:spPr>
+          <a:xfrm>
+            <a:off x="548640" y="5989320"/>
+            <a:ext cx="11064240" cy="365760"/>
+          </a:xfrm>
+          <a:prstGeom prst="rect">
+            <a:avLst/>
+          </a:prstGeom>
+          <a:noFill/>
+          <a:ln/>
+        </p:spPr>
+        <p:txBody>
+          <a:bodyPr wrap="square" lIns="0" tIns="0" rIns="0" bIns="0" rtlCol="0" anchor="ctr"/>
+          <a:lstStyle/>
+          <a:p>
+            <a:pPr indent="0" marL="0">
+              <a:buNone/>
+            </a:pPr>
+            <a:r>
+              <a:rPr lang="en-US" sz="1400" i="1" dirty="0">
+                <a:solidFill>
+                  <a:srgbClr val="3E4F66"/>
+                </a:solidFill>
+              </a:rPr>
+              <a:t>Portal do cliente (próximo passo): com login, ele cota sozinho digitando só código e quantidade.</a:t>
+            </a:r>
+            <a:endParaRPr lang="en-US" sz="1400" dirty="0"/>
+          </a:p>
+        </p:txBody>
+      </p:sp>
+      <p:sp>
+        <p:nvSpPr>
+          <p:cNvPr id="25" name="Slide Number Placeholder 0"/>
+          <p:cNvSpPr>
+            <a:spLocks noGrp="1"/>
+          </p:cNvSpPr>
+          <p:nvPr>
+            <p:ph type="sldNum" sz="quarter" idx="4294967295"/>
+          </p:nvPr>
+        </p:nvSpPr>
+        <p:spPr>
+          <a:xfrm>
+            <a:off x="11064240" y="6382512"/>
+            <a:ext cx="640080" cy="274320"/>
+          </a:xfrm>
+          <a:prstGeom prst="rect">
+            <a:avLst/>
+          </a:prstGeom>
+          <a:extLst>
+            <a:ext uri="{C572A759-6A51-4108-AA02-DFA0A04FC94B}">
+              <ma14:wrappingTextBoxFlag xmlns:ma14="http://schemas.microsoft.com/office/mac/drawingml/2011/main" val="0"/>
+            </a:ext>
+          </a:extLst>
+        </p:spPr>
+        <p:txBody>
+          <a:bodyPr/>
+          <a:lstStyle>
+            <a:lvl1pPr>
+              <a:defRPr sz="1100">
+                <a:solidFill>
+                  <a:srgbClr val="6B7A90"/>
+                </a:solidFill>
+              </a:defRPr>
+            </a:lvl1pPr>
+          </a:lstStyle>
+          <a:p>
+            <a:pPr algn="r"/>
+            <a:fld id="{F7021451-1387-4CA6-816F-3879F97B5CBC}" type="slidenum">
+              <a:rPr b="0" lang="en-US"/>
+              <a:t>8</a:t>
+            </a:fld>
+            <a:endParaRPr lang="en-US"/>
+          </a:p>
+        </p:txBody>
+      </p:sp>
+    </p:spTree>
+  </p:cSld>
+  <p:clrMapOvr>
+    <a:masterClrMapping/>
+  </p:clrMapOvr>
+</p:sld>
+</file>
+
+<file path=ppt/slides/slide9.xml><?xml version="1.0" encoding="utf-8"?>
+<p:sld xmlns:a="http://schemas.openxmlformats.org/drawingml/2006/main" xmlns:r="http://schemas.openxmlformats.org/officeDocument/2006/relationships" xmlns:p="http://schemas.openxmlformats.org/presentationml/2006/main">
+  <p:cSld name="Slide 9">
+    <p:spTree>
+      <p:nvGrpSpPr>
+        <p:cNvPr id="1" name=""/>
+        <p:cNvGrpSpPr/>
+        <p:nvPr/>
+      </p:nvGrpSpPr>
+      <p:grpSpPr>
+        <a:xfrm>
+          <a:off x="0" y="0"/>
+          <a:ext cx="0" cy="0"/>
+          <a:chOff x="0" y="0"/>
+          <a:chExt cx="0" cy="0"/>
+        </a:xfrm>
+      </p:grpSpPr>
+      <p:sp>
+        <p:nvSpPr>
+          <p:cNvPr id="2" name="Chamada"/>
+          <p:cNvSpPr txBox="1"/>
+          <p:nvPr/>
+        </p:nvSpPr>
+        <p:spPr>
+          <a:xfrm>
+            <a:off x="548640" y="365760"/>
+            <a:ext cx="8229600" cy="365760"/>
+          </a:xfrm>
+          <a:prstGeom prst="rect">
+            <a:avLst/>
+          </a:prstGeom>
+          <a:noFill/>
+          <a:ln/>
+        </p:spPr>
+        <p:txBody>
+          <a:bodyPr wrap="square" lIns="0" tIns="0" rIns="0" bIns="0" rtlCol="0" anchor="ctr"/>
+          <a:lstStyle/>
+          <a:p>
+            <a:pPr indent="0" marL="0">
+              <a:buNone/>
+            </a:pPr>
+            <a:r>
+              <a:rPr lang="en-US" sz="1400" b="1" spc="300" kern="0" dirty="0">
+                <a:solidFill>
+                  <a:schemeClr val="accent1"/>
+                </a:solidFill>
+              </a:rPr>
+              <a:t>VENDAS ONLINE</a:t>
+            </a:r>
+            <a:endParaRPr lang="en-US" sz="1400" dirty="0"/>
           </a:p>
         </p:txBody>
       </p:sp>
@@ -7251,13 +7767,13 @@
           <p:cNvPr id="3" name="Text 0"/>
           <p:cNvSpPr/>
           <p:nvPr>
-            <p:ph idx="101" type="body" hasCustomPrompt="1"/>
+            <p:ph idx="100" type="title" hasCustomPrompt="1"/>
           </p:nvPr>
         </p:nvSpPr>
         <p:spPr>
           <a:xfrm>
-            <a:off x="731520" y="4160520"/>
-            <a:ext cx="9692640" cy="1188720"/>
+            <a:off x="548640" y="777240"/>
+            <a:ext cx="11064240" cy="822960"/>
           </a:xfrm>
           <a:prstGeom prst="rect">
             <a:avLst/>
@@ -7273,14 +7789,741 @@
               <a:buNone/>
             </a:pPr>
             <a:r>
-              <a:rPr lang="en-US" sz="2200" dirty="0">
-                <a:solidFill>
-                  <a:schemeClr val="accent6"/>
-                </a:solidFill>
-              </a:rPr>
-              <a:t>[2] vendedores · medimos tempo de cotação de motor, cotações por dia e quantas viram pedido. Se não melhorar, paramos.</a:t>
+              <a:rPr lang="en-US" sz="3000" b="1" dirty="0">
+                <a:solidFill>
+                  <a:schemeClr val="tx1"/>
+                </a:solidFill>
+              </a:rPr>
+              <a:t>Um cadastro só, vendendo no site, no Mercado Livre e na Shopee</a:t>
+            </a:r>
+            <a:endParaRPr lang="en-US" sz="3000" dirty="0"/>
+          </a:p>
+        </p:txBody>
+      </p:sp>
+      <p:sp>
+        <p:nvSpPr>
+          <p:cNvPr id="4" name="PartsFlow"/>
+          <p:cNvSpPr/>
+          <p:nvPr/>
+        </p:nvSpPr>
+        <p:spPr>
+          <a:xfrm>
+            <a:off x="548640" y="1783080"/>
+            <a:ext cx="3566160" cy="3566160"/>
+          </a:xfrm>
+          <a:prstGeom prst="roundRect">
+            <a:avLst>
+              <a:gd name="adj" fmla="val 3077"/>
+            </a:avLst>
+          </a:prstGeom>
+          <a:solidFill>
+            <a:srgbClr val="13294B"/>
+          </a:solidFill>
+          <a:ln w="12700">
+            <a:solidFill>
+              <a:srgbClr val="13294B"/>
+            </a:solidFill>
+            <a:prstDash val="solid"/>
+          </a:ln>
+          <a:effectLst>
+            <a:outerShdw sx="100000" sy="100000" kx="0" ky="0" algn="bl" rotWithShape="0" blurRad="76200" dist="25400" dir="5400000">
+              <a:srgbClr val="000000">
+                <a:alpha val="10000"/>
+              </a:srgbClr>
+            </a:outerShdw>
+          </a:effectLst>
+        </p:spPr>
+      </p:sp>
+      <p:sp>
+        <p:nvSpPr>
+          <p:cNvPr id="5" name="Text 3"/>
+          <p:cNvSpPr txBox="1"/>
+          <p:nvPr/>
+        </p:nvSpPr>
+        <p:spPr>
+          <a:xfrm>
+            <a:off x="822960" y="1920240"/>
+            <a:ext cx="3108960" cy="777240"/>
+          </a:xfrm>
+          <a:prstGeom prst="rect">
+            <a:avLst/>
+          </a:prstGeom>
+          <a:noFill/>
+          <a:ln/>
+        </p:spPr>
+        <p:txBody>
+          <a:bodyPr wrap="square" lIns="0" tIns="0" rIns="0" bIns="0" rtlCol="0" anchor="ctr"/>
+          <a:lstStyle/>
+          <a:p>
+            <a:pPr indent="0" marL="0">
+              <a:buNone/>
+            </a:pPr>
+            <a:r>
+              <a:rPr lang="en-US" sz="2200" b="1" dirty="0">
+                <a:solidFill>
+                  <a:srgbClr val="F4F1EA"/>
+                </a:solidFill>
+              </a:rPr>
+              <a:t>PartsFlow</a:t>
             </a:r>
             <a:endParaRPr lang="en-US" sz="2200" dirty="0"/>
+          </a:p>
+          <a:p>
+            <a:pPr indent="0" marL="0">
+              <a:buNone/>
+            </a:pPr>
+            <a:r>
+              <a:rPr lang="en-US" sz="1300" dirty="0">
+                <a:solidFill>
+                  <a:srgbClr val="C9D6E8"/>
+                </a:solidFill>
+              </a:rPr>
+              <a:t>o que já temos:</a:t>
+            </a:r>
+            <a:endParaRPr lang="en-US" sz="2200" dirty="0"/>
+          </a:p>
+        </p:txBody>
+      </p:sp>
+      <p:sp>
+        <p:nvSpPr>
+          <p:cNvPr id="6" name="Text 4"/>
+          <p:cNvSpPr txBox="1"/>
+          <p:nvPr/>
+        </p:nvSpPr>
+        <p:spPr>
+          <a:xfrm>
+            <a:off x="822960" y="2743200"/>
+            <a:ext cx="3108960" cy="2926080"/>
+          </a:xfrm>
+          <a:prstGeom prst="rect">
+            <a:avLst/>
+          </a:prstGeom>
+          <a:noFill/>
+          <a:ln/>
+        </p:spPr>
+        <p:txBody>
+          <a:bodyPr wrap="square" lIns="0" tIns="0" rIns="0" bIns="0" rtlCol="0" anchor="t"/>
+          <a:lstStyle/>
+          <a:p>
+            <a:pPr marL="342900" indent="-342900">
+              <a:spcAft>
+                <a:spcPts val="600"/>
+              </a:spcAft>
+              <a:buSzPct val="100000"/>
+              <a:buChar char="•"/>
+            </a:pPr>
+            <a:r>
+              <a:rPr lang="en-US" sz="1500" dirty="0">
+                <a:solidFill>
+                  <a:srgbClr val="F4F1EA"/>
+                </a:solidFill>
+              </a:rPr>
+              <a:t>Descrição padrão</a:t>
+            </a:r>
+            <a:endParaRPr lang="en-US" sz="1500" dirty="0"/>
+          </a:p>
+          <a:p>
+            <a:pPr marL="342900" indent="-342900">
+              <a:spcAft>
+                <a:spcPts val="600"/>
+              </a:spcAft>
+              <a:buSzPct val="100000"/>
+              <a:buChar char="•"/>
+            </a:pPr>
+            <a:r>
+              <a:rPr lang="en-US" sz="1500" dirty="0">
+                <a:solidFill>
+                  <a:srgbClr val="F4F1EA"/>
+                </a:solidFill>
+              </a:rPr>
+              <a:t>Fotos e desenho</a:t>
+            </a:r>
+            <a:endParaRPr lang="en-US" sz="1500" dirty="0"/>
+          </a:p>
+          <a:p>
+            <a:pPr marL="342900" indent="-342900">
+              <a:spcAft>
+                <a:spcPts val="600"/>
+              </a:spcAft>
+              <a:buSzPct val="100000"/>
+              <a:buChar char="•"/>
+            </a:pPr>
+            <a:r>
+              <a:rPr lang="en-US" sz="1500" dirty="0">
+                <a:solidFill>
+                  <a:srgbClr val="F4F1EA"/>
+                </a:solidFill>
+              </a:rPr>
+              <a:t>Aplicação por veículo</a:t>
+            </a:r>
+            <a:endParaRPr lang="en-US" sz="1500" dirty="0"/>
+          </a:p>
+          <a:p>
+            <a:pPr marL="342900" indent="-342900">
+              <a:spcAft>
+                <a:spcPts val="600"/>
+              </a:spcAft>
+              <a:buSzPct val="100000"/>
+              <a:buChar char="•"/>
+            </a:pPr>
+            <a:r>
+              <a:rPr lang="en-US" sz="1500" dirty="0">
+                <a:solidFill>
+                  <a:srgbClr val="F4F1EA"/>
+                </a:solidFill>
+              </a:rPr>
+              <a:t>Conversões e equivalentes</a:t>
+            </a:r>
+            <a:endParaRPr lang="en-US" sz="1500" dirty="0"/>
+          </a:p>
+          <a:p>
+            <a:pPr marL="342900" indent="-342900">
+              <a:spcAft>
+                <a:spcPts val="600"/>
+              </a:spcAft>
+              <a:buSzPct val="100000"/>
+              <a:buChar char="•"/>
+            </a:pPr>
+            <a:r>
+              <a:rPr lang="en-US" sz="1500" dirty="0">
+                <a:solidFill>
+                  <a:srgbClr val="F4F1EA"/>
+                </a:solidFill>
+              </a:rPr>
+              <a:t>Saldo e preço</a:t>
+            </a:r>
+            <a:endParaRPr lang="en-US" sz="1500" dirty="0"/>
+          </a:p>
+        </p:txBody>
+      </p:sp>
+      <p:sp>
+        <p:nvSpPr>
+          <p:cNvPr id="7" name="Hub"/>
+          <p:cNvSpPr/>
+          <p:nvPr/>
+        </p:nvSpPr>
+        <p:spPr>
+          <a:xfrm>
+            <a:off x="4572000" y="2834640"/>
+            <a:ext cx="2377440" cy="1463040"/>
+          </a:xfrm>
+          <a:prstGeom prst="roundRect">
+            <a:avLst>
+              <a:gd name="adj" fmla="val 7500"/>
+            </a:avLst>
+          </a:prstGeom>
+          <a:solidFill>
+            <a:srgbClr val="E9EEF5"/>
+          </a:solidFill>
+          <a:ln w="12700">
+            <a:solidFill>
+              <a:srgbClr val="E9EEF5"/>
+            </a:solidFill>
+            <a:prstDash val="solid"/>
+          </a:ln>
+          <a:effectLst>
+            <a:outerShdw sx="100000" sy="100000" kx="0" ky="0" algn="bl" rotWithShape="0" blurRad="76200" dist="25400" dir="5400000">
+              <a:srgbClr val="000000">
+                <a:alpha val="10000"/>
+              </a:srgbClr>
+            </a:outerShdw>
+          </a:effectLst>
+        </p:spPr>
+      </p:sp>
+      <p:sp>
+        <p:nvSpPr>
+          <p:cNvPr id="8" name="Text 6"/>
+          <p:cNvSpPr txBox="1"/>
+          <p:nvPr/>
+        </p:nvSpPr>
+        <p:spPr>
+          <a:xfrm>
+            <a:off x="4709160" y="2907792"/>
+            <a:ext cx="2103120" cy="1325880"/>
+          </a:xfrm>
+          <a:prstGeom prst="rect">
+            <a:avLst/>
+          </a:prstGeom>
+          <a:noFill/>
+          <a:ln/>
+        </p:spPr>
+        <p:txBody>
+          <a:bodyPr wrap="square" lIns="0" tIns="0" rIns="0" bIns="0" rtlCol="0" anchor="ctr"/>
+          <a:lstStyle/>
+          <a:p>
+            <a:pPr algn="ctr" indent="0" marL="0">
+              <a:buNone/>
+            </a:pPr>
+            <a:r>
+              <a:rPr lang="en-US" sz="1700" b="1" dirty="0">
+                <a:solidFill>
+                  <a:srgbClr val="13294B"/>
+                </a:solidFill>
+              </a:rPr>
+              <a:t>Integrador</a:t>
+            </a:r>
+            <a:endParaRPr lang="en-US" sz="1700" dirty="0"/>
+          </a:p>
+          <a:p>
+            <a:pPr algn="ctr" indent="0" marL="0">
+              <a:buNone/>
+            </a:pPr>
+            <a:r>
+              <a:rPr lang="en-US" sz="1200" dirty="0">
+                <a:solidFill>
+                  <a:srgbClr val="3E4F66"/>
+                </a:solidFill>
+              </a:rPr>
+              <a:t>hub de marketplace ou API direta</a:t>
+            </a:r>
+            <a:endParaRPr lang="en-US" sz="1700" dirty="0"/>
+          </a:p>
+        </p:txBody>
+      </p:sp>
+      <p:sp>
+        <p:nvSpPr>
+          <p:cNvPr id="9" name="Seta"/>
+          <p:cNvSpPr/>
+          <p:nvPr/>
+        </p:nvSpPr>
+        <p:spPr>
+          <a:xfrm>
+            <a:off x="4160520" y="3364992"/>
+            <a:ext cx="365760" cy="411480"/>
+          </a:xfrm>
+          <a:prstGeom prst="rightArrow">
+            <a:avLst/>
+          </a:prstGeom>
+          <a:solidFill>
+            <a:schemeClr val="accent1"/>
+          </a:solidFill>
+          <a:ln w="12700">
+            <a:solidFill>
+              <a:schemeClr val="accent1"/>
+            </a:solidFill>
+            <a:prstDash val="solid"/>
+          </a:ln>
+        </p:spPr>
+      </p:sp>
+      <p:sp>
+        <p:nvSpPr>
+          <p:cNvPr id="10" name="Seta"/>
+          <p:cNvSpPr/>
+          <p:nvPr/>
+        </p:nvSpPr>
+        <p:spPr>
+          <a:xfrm>
+            <a:off x="6995160" y="3364992"/>
+            <a:ext cx="365760" cy="411480"/>
+          </a:xfrm>
+          <a:prstGeom prst="rightArrow">
+            <a:avLst/>
+          </a:prstGeom>
+          <a:solidFill>
+            <a:schemeClr val="accent1"/>
+          </a:solidFill>
+          <a:ln w="12700">
+            <a:solidFill>
+              <a:schemeClr val="accent1"/>
+            </a:solidFill>
+            <a:prstDash val="solid"/>
+          </a:ln>
+        </p:spPr>
+      </p:sp>
+      <p:sp>
+        <p:nvSpPr>
+          <p:cNvPr id="11" name="Cartão"/>
+          <p:cNvSpPr/>
+          <p:nvPr/>
+        </p:nvSpPr>
+        <p:spPr>
+          <a:xfrm>
+            <a:off x="7452360" y="1783080"/>
+            <a:ext cx="4160520" cy="740664"/>
+          </a:xfrm>
+          <a:prstGeom prst="roundRect">
+            <a:avLst>
+              <a:gd name="adj" fmla="val 14815"/>
+            </a:avLst>
+          </a:prstGeom>
+          <a:solidFill>
+            <a:srgbClr val="E9EEF5"/>
+          </a:solidFill>
+          <a:ln w="12700">
+            <a:solidFill>
+              <a:srgbClr val="E9EEF5"/>
+            </a:solidFill>
+            <a:prstDash val="solid"/>
+          </a:ln>
+          <a:effectLst>
+            <a:outerShdw sx="100000" sy="100000" kx="0" ky="0" algn="bl" rotWithShape="0" blurRad="76200" dist="25400" dir="5400000">
+              <a:srgbClr val="000000">
+                <a:alpha val="10000"/>
+              </a:srgbClr>
+            </a:outerShdw>
+          </a:effectLst>
+        </p:spPr>
+      </p:sp>
+      <p:sp>
+        <p:nvSpPr>
+          <p:cNvPr id="12" name="Text 10"/>
+          <p:cNvSpPr txBox="1"/>
+          <p:nvPr/>
+        </p:nvSpPr>
+        <p:spPr>
+          <a:xfrm>
+            <a:off x="7680960" y="1783080"/>
+            <a:ext cx="3749040" cy="740664"/>
+          </a:xfrm>
+          <a:prstGeom prst="rect">
+            <a:avLst/>
+          </a:prstGeom>
+          <a:noFill/>
+          <a:ln/>
+        </p:spPr>
+        <p:txBody>
+          <a:bodyPr wrap="square" lIns="0" tIns="0" rIns="0" bIns="0" rtlCol="0" anchor="ctr"/>
+          <a:lstStyle/>
+          <a:p>
+            <a:pPr indent="0" marL="0">
+              <a:buNone/>
+            </a:pPr>
+            <a:r>
+              <a:rPr lang="en-US" sz="1700" b="1" dirty="0">
+                <a:solidFill>
+                  <a:srgbClr val="13294B"/>
+                </a:solidFill>
+              </a:rPr>
+              <a:t>Nosso site</a:t>
+            </a:r>
+            <a:endParaRPr lang="en-US" sz="1700" dirty="0"/>
+          </a:p>
+        </p:txBody>
+      </p:sp>
+      <p:sp>
+        <p:nvSpPr>
+          <p:cNvPr id="13" name="Cartão"/>
+          <p:cNvSpPr/>
+          <p:nvPr/>
+        </p:nvSpPr>
+        <p:spPr>
+          <a:xfrm>
+            <a:off x="7452360" y="2724912"/>
+            <a:ext cx="4160520" cy="740664"/>
+          </a:xfrm>
+          <a:prstGeom prst="roundRect">
+            <a:avLst>
+              <a:gd name="adj" fmla="val 14815"/>
+            </a:avLst>
+          </a:prstGeom>
+          <a:solidFill>
+            <a:srgbClr val="E9EEF5"/>
+          </a:solidFill>
+          <a:ln w="12700">
+            <a:solidFill>
+              <a:srgbClr val="E9EEF5"/>
+            </a:solidFill>
+            <a:prstDash val="solid"/>
+          </a:ln>
+          <a:effectLst>
+            <a:outerShdw sx="100000" sy="100000" kx="0" ky="0" algn="bl" rotWithShape="0" blurRad="76200" dist="25400" dir="5400000">
+              <a:srgbClr val="000000">
+                <a:alpha val="10000"/>
+              </a:srgbClr>
+            </a:outerShdw>
+          </a:effectLst>
+        </p:spPr>
+      </p:sp>
+      <p:sp>
+        <p:nvSpPr>
+          <p:cNvPr id="14" name="Text 12"/>
+          <p:cNvSpPr txBox="1"/>
+          <p:nvPr/>
+        </p:nvSpPr>
+        <p:spPr>
+          <a:xfrm>
+            <a:off x="7680960" y="2724912"/>
+            <a:ext cx="3749040" cy="740664"/>
+          </a:xfrm>
+          <a:prstGeom prst="rect">
+            <a:avLst/>
+          </a:prstGeom>
+          <a:noFill/>
+          <a:ln/>
+        </p:spPr>
+        <p:txBody>
+          <a:bodyPr wrap="square" lIns="0" tIns="0" rIns="0" bIns="0" rtlCol="0" anchor="ctr"/>
+          <a:lstStyle/>
+          <a:p>
+            <a:pPr indent="0" marL="0">
+              <a:buNone/>
+            </a:pPr>
+            <a:r>
+              <a:rPr lang="en-US" sz="1700" b="1" dirty="0">
+                <a:solidFill>
+                  <a:srgbClr val="13294B"/>
+                </a:solidFill>
+              </a:rPr>
+              <a:t>Mercado Livre</a:t>
+            </a:r>
+            <a:endParaRPr lang="en-US" sz="1700" dirty="0"/>
+          </a:p>
+        </p:txBody>
+      </p:sp>
+      <p:sp>
+        <p:nvSpPr>
+          <p:cNvPr id="15" name="Cartão"/>
+          <p:cNvSpPr/>
+          <p:nvPr/>
+        </p:nvSpPr>
+        <p:spPr>
+          <a:xfrm>
+            <a:off x="7452360" y="3666744"/>
+            <a:ext cx="4160520" cy="740664"/>
+          </a:xfrm>
+          <a:prstGeom prst="roundRect">
+            <a:avLst>
+              <a:gd name="adj" fmla="val 14815"/>
+            </a:avLst>
+          </a:prstGeom>
+          <a:solidFill>
+            <a:srgbClr val="E9EEF5"/>
+          </a:solidFill>
+          <a:ln w="12700">
+            <a:solidFill>
+              <a:srgbClr val="E9EEF5"/>
+            </a:solidFill>
+            <a:prstDash val="solid"/>
+          </a:ln>
+          <a:effectLst>
+            <a:outerShdw sx="100000" sy="100000" kx="0" ky="0" algn="bl" rotWithShape="0" blurRad="76200" dist="25400" dir="5400000">
+              <a:srgbClr val="000000">
+                <a:alpha val="10000"/>
+              </a:srgbClr>
+            </a:outerShdw>
+          </a:effectLst>
+        </p:spPr>
+      </p:sp>
+      <p:sp>
+        <p:nvSpPr>
+          <p:cNvPr id="16" name="Text 14"/>
+          <p:cNvSpPr txBox="1"/>
+          <p:nvPr/>
+        </p:nvSpPr>
+        <p:spPr>
+          <a:xfrm>
+            <a:off x="7680960" y="3666744"/>
+            <a:ext cx="3749040" cy="740664"/>
+          </a:xfrm>
+          <a:prstGeom prst="rect">
+            <a:avLst/>
+          </a:prstGeom>
+          <a:noFill/>
+          <a:ln/>
+        </p:spPr>
+        <p:txBody>
+          <a:bodyPr wrap="square" lIns="0" tIns="0" rIns="0" bIns="0" rtlCol="0" anchor="ctr"/>
+          <a:lstStyle/>
+          <a:p>
+            <a:pPr indent="0" marL="0">
+              <a:buNone/>
+            </a:pPr>
+            <a:r>
+              <a:rPr lang="en-US" sz="1700" b="1" dirty="0">
+                <a:solidFill>
+                  <a:srgbClr val="13294B"/>
+                </a:solidFill>
+              </a:rPr>
+              <a:t>Shopee</a:t>
+            </a:r>
+            <a:endParaRPr lang="en-US" sz="1700" dirty="0"/>
+          </a:p>
+        </p:txBody>
+      </p:sp>
+      <p:sp>
+        <p:nvSpPr>
+          <p:cNvPr id="17" name="Cartão"/>
+          <p:cNvSpPr/>
+          <p:nvPr/>
+        </p:nvSpPr>
+        <p:spPr>
+          <a:xfrm>
+            <a:off x="7452360" y="4608576"/>
+            <a:ext cx="4160520" cy="740664"/>
+          </a:xfrm>
+          <a:prstGeom prst="roundRect">
+            <a:avLst>
+              <a:gd name="adj" fmla="val 14815"/>
+            </a:avLst>
+          </a:prstGeom>
+          <a:solidFill>
+            <a:srgbClr val="E9EEF5"/>
+          </a:solidFill>
+          <a:ln w="12700">
+            <a:solidFill>
+              <a:srgbClr val="E9EEF5"/>
+            </a:solidFill>
+            <a:prstDash val="solid"/>
+          </a:ln>
+          <a:effectLst>
+            <a:outerShdw sx="100000" sy="100000" kx="0" ky="0" algn="bl" rotWithShape="0" blurRad="76200" dist="25400" dir="5400000">
+              <a:srgbClr val="000000">
+                <a:alpha val="10000"/>
+              </a:srgbClr>
+            </a:outerShdw>
+          </a:effectLst>
+        </p:spPr>
+      </p:sp>
+      <p:sp>
+        <p:nvSpPr>
+          <p:cNvPr id="18" name="Text 16"/>
+          <p:cNvSpPr txBox="1"/>
+          <p:nvPr/>
+        </p:nvSpPr>
+        <p:spPr>
+          <a:xfrm>
+            <a:off x="7680960" y="4608576"/>
+            <a:ext cx="3749040" cy="740664"/>
+          </a:xfrm>
+          <a:prstGeom prst="rect">
+            <a:avLst/>
+          </a:prstGeom>
+          <a:noFill/>
+          <a:ln/>
+        </p:spPr>
+        <p:txBody>
+          <a:bodyPr wrap="square" lIns="0" tIns="0" rIns="0" bIns="0" rtlCol="0" anchor="ctr"/>
+          <a:lstStyle/>
+          <a:p>
+            <a:pPr indent="0" marL="0">
+              <a:buNone/>
+            </a:pPr>
+            <a:r>
+              <a:rPr lang="en-US" sz="1700" b="1" dirty="0">
+                <a:solidFill>
+                  <a:srgbClr val="13294B"/>
+                </a:solidFill>
+              </a:rPr>
+              <a:t>Outros (Amazon, Magalu…)</a:t>
+            </a:r>
+            <a:endParaRPr lang="en-US" sz="1700" dirty="0"/>
+          </a:p>
+        </p:txBody>
+      </p:sp>
+      <p:sp>
+        <p:nvSpPr>
+          <p:cNvPr id="19" name="Text 17"/>
+          <p:cNvSpPr txBox="1"/>
+          <p:nvPr/>
+        </p:nvSpPr>
+        <p:spPr>
+          <a:xfrm>
+            <a:off x="548640" y="5577840"/>
+            <a:ext cx="11064240" cy="640080"/>
+          </a:xfrm>
+          <a:prstGeom prst="rect">
+            <a:avLst/>
+          </a:prstGeom>
+          <a:noFill/>
+          <a:ln/>
+        </p:spPr>
+        <p:txBody>
+          <a:bodyPr wrap="square" lIns="0" tIns="0" rIns="0" bIns="0" rtlCol="0" anchor="ctr"/>
+          <a:lstStyle/>
+          <a:p>
+            <a:pPr indent="0" marL="0">
+              <a:buNone/>
+            </a:pPr>
+            <a:r>
+              <a:rPr lang="en-US" sz="1400" b="1" dirty="0">
+                <a:solidFill>
+                  <a:srgbClr val="C2591F"/>
+                </a:solidFill>
+              </a:rPr>
+              <a:t>→ vai: </a:t>
+            </a:r>
+            <a:pPr indent="0" marL="0">
+              <a:buNone/>
+            </a:pPr>
+            <a:r>
+              <a:rPr lang="en-US" sz="1400" dirty="0">
+                <a:solidFill>
+                  <a:srgbClr val="3E4F66"/>
+                </a:solidFill>
+              </a:rPr>
+              <a:t>anúncio com foto, descrição e compatibilidade de veículo · saldo e preço atualizados sozinhos</a:t>
+            </a:r>
+            <a:endParaRPr lang="en-US" sz="1400" dirty="0"/>
+          </a:p>
+          <a:p>
+            <a:pPr indent="0" marL="0">
+              <a:buNone/>
+            </a:pPr>
+            <a:r>
+              <a:rPr lang="en-US" sz="1400" b="1" dirty="0">
+                <a:solidFill>
+                  <a:srgbClr val="1E8449"/>
+                </a:solidFill>
+              </a:rPr>
+              <a:t>← volta: </a:t>
+            </a:r>
+            <a:pPr indent="0" marL="0">
+              <a:buNone/>
+            </a:pPr>
+            <a:r>
+              <a:rPr lang="en-US" sz="1400" dirty="0">
+                <a:solidFill>
+                  <a:srgbClr val="3E4F66"/>
+                </a:solidFill>
+              </a:rPr>
+              <a:t>pedidos e perguntas entram no PartsFlow e seguem pro ERP</a:t>
+            </a:r>
+            <a:endParaRPr lang="en-US" sz="1400" dirty="0"/>
+          </a:p>
+        </p:txBody>
+      </p:sp>
+      <p:sp>
+        <p:nvSpPr>
+          <p:cNvPr id="25" name="Slide Number Placeholder 0"/>
+          <p:cNvSpPr>
+            <a:spLocks noGrp="1"/>
+          </p:cNvSpPr>
+          <p:nvPr>
+            <p:ph type="sldNum" sz="quarter" idx="4294967295"/>
+          </p:nvPr>
+        </p:nvSpPr>
+        <p:spPr>
+          <a:xfrm>
+            <a:off x="11064240" y="6382512"/>
+            <a:ext cx="640080" cy="274320"/>
+          </a:xfrm>
+          <a:prstGeom prst="rect">
+            <a:avLst/>
+          </a:prstGeom>
+          <a:extLst>
+            <a:ext uri="{C572A759-6A51-4108-AA02-DFA0A04FC94B}">
+              <ma14:wrappingTextBoxFlag xmlns:ma14="http://schemas.microsoft.com/office/mac/drawingml/2011/main" val="0"/>
+            </a:ext>
+          </a:extLst>
+        </p:spPr>
+        <p:txBody>
+          <a:bodyPr/>
+          <a:lstStyle>
+            <a:lvl1pPr>
+              <a:defRPr sz="1100">
+                <a:solidFill>
+                  <a:srgbClr val="6B7A90"/>
+                </a:solidFill>
+              </a:defRPr>
+            </a:lvl1pPr>
+          </a:lstStyle>
+          <a:p>
+            <a:pPr algn="r"/>
+            <a:fld id="{F7021451-1387-4CA6-816F-3879F97B5CBC}" type="slidenum">
+              <a:rPr b="0" lang="en-US"/>
+              <a:t>9</a:t>
+            </a:fld>
+            <a:endParaRPr lang="en-US"/>
           </a:p>
         </p:txBody>
       </p:sp>

</xml_diff>

<commit_message>
Apresentação: prévia do portal (cliente cota só com código) e slide de vendas online (#291)
Claude-Session: https://claude.ai/code/session_01AHZHvPsx9zvMYGTsdyQVMz

Co-authored-by: Claude <noreply@anthropic.com>
</commit_message>
<xml_diff>
--- a/docs/apresentacao/PartsFlow-apresentacao-curta.pptx
+++ b/docs/apresentacao/PartsFlow-apresentacao-curta.pptx
@@ -13,9 +13,11 @@
     <p:sldId id="261" r:id="rId7"/>
     <p:sldId id="262" r:id="rId8"/>
     <p:sldId id="263" r:id="rId9"/>
+    <p:sldId id="264" r:id="rId10"/>
+    <p:sldId id="265" r:id="rId11"/>
   </p:sldIdLst>
   <p:notesMasterIdLst>
-    <p:notesMasterId r:id="rId10"/>
+    <p:notesMasterId r:id="rId12"/>
   </p:notesMasterIdLst>
   <p:sldSz cx="12192000" cy="6858000"/>
   <p:notesSz cx="6858000" cy="12192000"/>
@@ -114,32 +116,34 @@
   <p:extLst>
     <p:ext uri="{521415D9-36F7-43E2-AB2F-B90AF26B5E84}">
       <p14:sectionLst xmlns:p14="http://schemas.microsoft.com/office/powerpoint/2010/main">
-        <p14:section name="O ganho" id="{84801a51-b860-24ba-9c06-e3ccbe987a91}">
+        <p14:section name="O ganho" id="{0f7d58f8-16b0-ce21-c291-b76ea330f170}">
           <p14:sldIdLst>
             <p14:sldId id="256"/>
             <p14:sldId id="257"/>
           </p14:sldIdLst>
         </p14:section>
-        <p14:section name="A cotação" id="{f1740997-b36e-499b-0e9a-8f630f18e350}">
+        <p14:section name="A cotação" id="{552ac0e8-5e94-f40d-c9af-3988d3e94fef}">
           <p14:sldIdLst>
             <p14:sldId id="258"/>
             <p14:sldId id="259"/>
           </p14:sldIdLst>
         </p14:section>
-        <p14:section name="A carteira" id="{8fc60e47-7eda-1b30-1812-66e82ed6e6bb}">
+        <p14:section name="A carteira" id="{a849ae14-2a98-3af3-68ab-29febccaee8d}">
           <p14:sldIdLst>
             <p14:sldId id="260"/>
             <p14:sldId id="261"/>
-          </p14:sldIdLst>
-        </p14:section>
-        <p14:section name="Futuro" id="{e7ef207e-2d53-3c6a-bc92-988a899f3f1d}">
-          <p14:sldIdLst>
             <p14:sldId id="262"/>
           </p14:sldIdLst>
         </p14:section>
-        <p14:section name="Proposta" id="{19d21df5-93f4-5ab4-6024-c0ddd2a6641d}">
+        <p14:section name="Futuro" id="{69917ba7-9d11-2594-62f4-9f239f71806f}">
           <p14:sldIdLst>
             <p14:sldId id="263"/>
+            <p14:sldId id="264"/>
+          </p14:sldIdLst>
+        </p14:section>
+        <p14:section name="Proposta" id="{23fd055b-c34b-87c7-4545-2e108ba8048f}">
+          <p14:sldIdLst>
+            <p14:sldId id="265"/>
           </p14:sldIdLst>
         </p14:section>
       </p14:sectionLst>
@@ -588,6 +592,94 @@
 </p:notes>
 </file>
 
+<file path=ppt/notesSlides/notesSlide10.xml><?xml version="1.0" encoding="utf-8"?>
+<p:notes xmlns:a="http://schemas.openxmlformats.org/drawingml/2006/main" xmlns:r="http://schemas.openxmlformats.org/officeDocument/2006/relationships" xmlns:p="http://schemas.openxmlformats.org/presentationml/2006/main">
+  <p:cSld>
+    <p:spTree>
+      <p:nvGrpSpPr>
+        <p:cNvPr id="1" name=""/>
+        <p:cNvGrpSpPr/>
+        <p:nvPr/>
+      </p:nvGrpSpPr>
+      <p:grpSpPr>
+        <a:xfrm>
+          <a:off x="0" y="0"/>
+          <a:ext cx="0" cy="0"/>
+          <a:chOff x="0" y="0"/>
+          <a:chExt cx="0" cy="0"/>
+        </a:xfrm>
+      </p:grpSpPr>
+      <p:sp>
+        <p:nvSpPr>
+          <p:cNvPr id="2" name="Slide Image Placeholder 1"/>
+          <p:cNvSpPr>
+            <a:spLocks noGrp="1" noRot="1" noChangeAspect="1"/>
+          </p:cNvSpPr>
+          <p:nvPr>
+            <p:ph type="sldImg"/>
+          </p:nvPr>
+        </p:nvSpPr>
+        <p:spPr/>
+      </p:sp>
+      <p:sp>
+        <p:nvSpPr>
+          <p:cNvPr id="3" name="Notes Placeholder 2"/>
+          <p:cNvSpPr>
+            <a:spLocks noGrp="1"/>
+          </p:cNvSpPr>
+          <p:nvPr>
+            <p:ph type="body" idx="1"/>
+          </p:nvPr>
+        </p:nvSpPr>
+        <p:spPr/>
+        <p:txBody>
+          <a:bodyPr/>
+          <a:lstStyle/>
+          <a:p>
+            <a:r>
+              <a:rPr lang="en-US" dirty="0"/>
+              <a:t>Pedir pouco e com saída fácil. Pergunta fechada no final: posso começar com [nome] e [nome] na segunda?</a:t>
+            </a:r>
+            <a:endParaRPr lang="en-US" dirty="0"/>
+          </a:p>
+        </p:txBody>
+      </p:sp>
+      <p:sp>
+        <p:nvSpPr>
+          <p:cNvPr id="4" name="Slide Number Placeholder 3"/>
+          <p:cNvSpPr>
+            <a:spLocks noGrp="1"/>
+          </p:cNvSpPr>
+          <p:nvPr>
+            <p:ph type="sldNum" sz="quarter" idx="10"/>
+          </p:nvPr>
+        </p:nvSpPr>
+        <p:spPr/>
+        <p:txBody>
+          <a:bodyPr/>
+          <a:lstStyle/>
+          <a:p>
+            <a:fld id="{F7021451-1387-4CA6-816F-3879F97B5CBC}" type="slidenum">
+              <a:rPr lang="en-US"/>
+              <a:t>10</a:t>
+            </a:fld>
+            <a:endParaRPr lang="en-US"/>
+          </a:p>
+        </p:txBody>
+      </p:sp>
+    </p:spTree>
+    <p:extLst>
+      <p:ext uri="{BB962C8B-B14F-4D97-AF65-F5344CB8AC3E}">
+        <p14:creationId xmlns:p14="http://schemas.microsoft.com/office/powerpoint/2010/main" val="1024086991"/>
+      </p:ext>
+    </p:extLst>
+  </p:cSld>
+  <p:clrMapOvr>
+    <a:masterClrMapping/>
+  </p:clrMapOvr>
+</p:notes>
+</file>
+
 <file path=ppt/notesSlides/notesSlide2.xml><?xml version="1.0" encoding="utf-8"?>
 <p:notes xmlns:a="http://schemas.openxmlformats.org/drawingml/2006/main" xmlns:r="http://schemas.openxmlformats.org/officeDocument/2006/relationships" xmlns:p="http://schemas.openxmlformats.org/presentationml/2006/main">
   <p:cSld>
@@ -1074,7 +1166,7 @@
           <a:p>
             <a:r>
               <a:rPr lang="en-US" dirty="0"/>
-              <a:t>Não prometer data: mostrar que o caminho existe. Começa ao lado do JBoss, sem risco. Com o tempo, integra: o saldo e os pedidos do ERP entram sozinhos, o cadastro alimenta o site e o Vendas On, e os avisos vão pelo WhatsApp oficial.</a:t>
+              <a:t>Deixar claro que é PRÉVIA, o próximo passo. O cliente entra com login, digita o código que ele tem (de qualquer marca, o sistema converte) e a quantidade, ou cola a lista. Vê na hora disponibilidade e preço da tabela dele. O que é pequeno e tem saldo sai sozinho; o resto chega pronto pro vendedor, com nota de prioridade. O vendedor para de digitar cotação e vai cuidar da carteira.</a:t>
             </a:r>
             <a:endParaRPr lang="en-US" dirty="0"/>
           </a:p>
@@ -1162,7 +1254,7 @@
           <a:p>
             <a:r>
               <a:rPr lang="en-US" dirty="0"/>
-              <a:t>Pedir pouco e com saída fácil. Pergunta fechada no final: posso começar com [nome] e [nome] na segunda?</a:t>
+              <a:t>Não prometer data: mostrar que o caminho existe. Começa ao lado do JBoss, sem risco. Com o tempo, integra: o saldo e os pedidos do ERP entram sozinhos, o cadastro alimenta o site e o Vendas On, e os avisos vão pelo WhatsApp oficial.</a:t>
             </a:r>
             <a:endParaRPr lang="en-US" dirty="0"/>
           </a:p>
@@ -1186,6 +1278,94 @@
             <a:fld id="{F7021451-1387-4CA6-816F-3879F97B5CBC}" type="slidenum">
               <a:rPr lang="en-US"/>
               <a:t>8</a:t>
+            </a:fld>
+            <a:endParaRPr lang="en-US"/>
+          </a:p>
+        </p:txBody>
+      </p:sp>
+    </p:spTree>
+    <p:extLst>
+      <p:ext uri="{BB962C8B-B14F-4D97-AF65-F5344CB8AC3E}">
+        <p14:creationId xmlns:p14="http://schemas.microsoft.com/office/powerpoint/2010/main" val="1024086991"/>
+      </p:ext>
+    </p:extLst>
+  </p:cSld>
+  <p:clrMapOvr>
+    <a:masterClrMapping/>
+  </p:clrMapOvr>
+</p:notes>
+</file>
+
+<file path=ppt/notesSlides/notesSlide9.xml><?xml version="1.0" encoding="utf-8"?>
+<p:notes xmlns:a="http://schemas.openxmlformats.org/drawingml/2006/main" xmlns:r="http://schemas.openxmlformats.org/officeDocument/2006/relationships" xmlns:p="http://schemas.openxmlformats.org/presentationml/2006/main">
+  <p:cSld>
+    <p:spTree>
+      <p:nvGrpSpPr>
+        <p:cNvPr id="1" name=""/>
+        <p:cNvGrpSpPr/>
+        <p:nvPr/>
+      </p:nvGrpSpPr>
+      <p:grpSpPr>
+        <a:xfrm>
+          <a:off x="0" y="0"/>
+          <a:ext cx="0" cy="0"/>
+          <a:chOff x="0" y="0"/>
+          <a:chExt cx="0" cy="0"/>
+        </a:xfrm>
+      </p:grpSpPr>
+      <p:sp>
+        <p:nvSpPr>
+          <p:cNvPr id="2" name="Slide Image Placeholder 1"/>
+          <p:cNvSpPr>
+            <a:spLocks noGrp="1" noRot="1" noChangeAspect="1"/>
+          </p:cNvSpPr>
+          <p:nvPr>
+            <p:ph type="sldImg"/>
+          </p:nvPr>
+        </p:nvSpPr>
+        <p:spPr/>
+      </p:sp>
+      <p:sp>
+        <p:nvSpPr>
+          <p:cNvPr id="3" name="Notes Placeholder 2"/>
+          <p:cNvSpPr>
+            <a:spLocks noGrp="1"/>
+          </p:cNvSpPr>
+          <p:nvPr>
+            <p:ph type="body" idx="1"/>
+          </p:nvPr>
+        </p:nvSpPr>
+        <p:spPr/>
+        <p:txBody>
+          <a:bodyPr/>
+          <a:lstStyle/>
+          <a:p>
+            <a:r>
+              <a:rPr lang="en-US" dirty="0"/>
+              <a:t>O trabalho mais pesado do e-commerce de autopeça é o cadastro: descrição, foto e compatibilidade. Isso o PartsFlow já tem. Caminho mais simples: um integrador (hub de marketplace, ex. Bling, Tiny, ANYMARKET) que já fala com Mercado Livre, Shopee e loja virtual; o PartsFlow manda cadastro, saldo e preço pro hub, e os pedidos voltam. Caminho mais completo: API direta do Mercado Livre e da Shopee. Em qualquer um, um só cadastro e um só estoque.</a:t>
+            </a:r>
+            <a:endParaRPr lang="en-US" dirty="0"/>
+          </a:p>
+        </p:txBody>
+      </p:sp>
+      <p:sp>
+        <p:nvSpPr>
+          <p:cNvPr id="4" name="Slide Number Placeholder 3"/>
+          <p:cNvSpPr>
+            <a:spLocks noGrp="1"/>
+          </p:cNvSpPr>
+          <p:nvPr>
+            <p:ph type="sldNum" sz="quarter" idx="10"/>
+          </p:nvPr>
+        </p:nvSpPr>
+        <p:spPr/>
+        <p:txBody>
+          <a:bodyPr/>
+          <a:lstStyle/>
+          <a:p>
+            <a:fld id="{F7021451-1387-4CA6-816F-3879F97B5CBC}" type="slidenum">
+              <a:rPr lang="en-US"/>
+              <a:t>9</a:t>
             </a:fld>
             <a:endParaRPr lang="en-US"/>
           </a:p>
@@ -2313,6 +2493,121 @@
 </p:sld>
 </file>
 
+<file path=ppt/slides/slide10.xml><?xml version="1.0" encoding="utf-8"?>
+<p:sld xmlns:a="http://schemas.openxmlformats.org/drawingml/2006/main" xmlns:r="http://schemas.openxmlformats.org/officeDocument/2006/relationships" xmlns:p="http://schemas.openxmlformats.org/presentationml/2006/main">
+  <p:cSld name="Slide 10">
+    <p:spTree>
+      <p:nvGrpSpPr>
+        <p:cNvPr id="1" name=""/>
+        <p:cNvGrpSpPr/>
+        <p:nvPr/>
+      </p:nvGrpSpPr>
+      <p:grpSpPr>
+        <a:xfrm>
+          <a:off x="0" y="0"/>
+          <a:ext cx="0" cy="0"/>
+          <a:chOff x="0" y="0"/>
+          <a:chExt cx="0" cy="0"/>
+        </a:xfrm>
+      </p:grpSpPr>
+      <p:sp>
+        <p:nvSpPr>
+          <p:cNvPr id="2" name="Text 0"/>
+          <p:cNvSpPr/>
+          <p:nvPr>
+            <p:ph idx="100" type="title" hasCustomPrompt="1"/>
+          </p:nvPr>
+        </p:nvSpPr>
+        <p:spPr>
+          <a:xfrm>
+            <a:off x="731520" y="1828800"/>
+            <a:ext cx="10607040" cy="2103120"/>
+          </a:xfrm>
+          <a:prstGeom prst="rect">
+            <a:avLst/>
+          </a:prstGeom>
+          <a:noFill/>
+          <a:ln/>
+        </p:spPr>
+        <p:txBody>
+          <a:bodyPr wrap="square" lIns="0" tIns="0" rIns="0" bIns="0" rtlCol="0" anchor="t"/>
+          <a:lstStyle/>
+          <a:p>
+            <a:pPr algn="l" indent="0" marL="0">
+              <a:buNone/>
+            </a:pPr>
+            <a:r>
+              <a:rPr lang="en-US" sz="5200" b="1" dirty="0">
+                <a:solidFill>
+                  <a:schemeClr val="accent4"/>
+                </a:solidFill>
+              </a:rPr>
+              <a:t>Piloto de 30 dias.</a:t>
+            </a:r>
+            <a:endParaRPr lang="en-US" sz="5200" dirty="0"/>
+          </a:p>
+          <a:p>
+            <a:pPr algn="l" indent="0" marL="0">
+              <a:buNone/>
+            </a:pPr>
+            <a:r>
+              <a:rPr lang="en-US" sz="5200" b="1" dirty="0">
+                <a:solidFill>
+                  <a:schemeClr val="accent2"/>
+                </a:solidFill>
+              </a:rPr>
+              <a:t>Sem mexer no ERP.</a:t>
+            </a:r>
+            <a:endParaRPr lang="en-US" sz="5200" dirty="0"/>
+          </a:p>
+        </p:txBody>
+      </p:sp>
+      <p:sp>
+        <p:nvSpPr>
+          <p:cNvPr id="3" name="Text 0"/>
+          <p:cNvSpPr/>
+          <p:nvPr>
+            <p:ph idx="101" type="body" hasCustomPrompt="1"/>
+          </p:nvPr>
+        </p:nvSpPr>
+        <p:spPr>
+          <a:xfrm>
+            <a:off x="731520" y="4160520"/>
+            <a:ext cx="9692640" cy="1188720"/>
+          </a:xfrm>
+          <a:prstGeom prst="rect">
+            <a:avLst/>
+          </a:prstGeom>
+          <a:noFill/>
+          <a:ln/>
+        </p:spPr>
+        <p:txBody>
+          <a:bodyPr wrap="square" lIns="0" tIns="0" rIns="0" bIns="0" rtlCol="0" anchor="t"/>
+          <a:lstStyle/>
+          <a:p>
+            <a:pPr algn="l" indent="0" marL="0">
+              <a:buNone/>
+            </a:pPr>
+            <a:r>
+              <a:rPr lang="en-US" sz="2200" dirty="0">
+                <a:solidFill>
+                  <a:schemeClr val="accent6"/>
+                </a:solidFill>
+              </a:rPr>
+              <a:t>[2] vendedores · medimos tempo de cotação de motor, cotações por dia e quantas viram pedido. Se não melhorar, paramos.</a:t>
+            </a:r>
+            <a:endParaRPr lang="en-US" sz="2200" dirty="0"/>
+          </a:p>
+        </p:txBody>
+      </p:sp>
+    </p:spTree>
+  </p:cSld>
+  <p:clrMapOvr>
+    <a:masterClrMapping/>
+  </p:clrMapOvr>
+</p:sld>
+</file>
+
 <file path=ppt/slides/slide2.xml><?xml version="1.0" encoding="utf-8"?>
 <p:sld xmlns:a="http://schemas.openxmlformats.org/drawingml/2006/main" xmlns:r="http://schemas.openxmlformats.org/officeDocument/2006/relationships" xmlns:p="http://schemas.openxmlformats.org/presentationml/2006/main">
   <p:cSld name="Slide 2">
@@ -6553,7 +6848,7 @@
                   <a:schemeClr val="accent1"/>
                 </a:solidFill>
               </a:rPr>
-              <a:t>DAQUI PRA FRENTE</a:t>
+              <a:t>PRÓXIMO PASSO · PRÉVIA</a:t>
             </a:r>
             <a:endParaRPr lang="en-US" sz="1400" dirty="0"/>
           </a:p>
@@ -6591,7 +6886,7 @@
                   <a:schemeClr val="tx1"/>
                 </a:solidFill>
               </a:rPr>
-              <a:t>Hoje ao lado do JBoss. Amanhã, integrado.</a:t>
+              <a:t>O cliente cota sozinho, só com o código e a quantidade</a:t>
             </a:r>
             <a:endParaRPr lang="en-US" sz="3000" dirty="0"/>
           </a:p>
@@ -6599,89 +6894,26 @@
       </p:sp>
       <p:sp>
         <p:nvSpPr>
-          <p:cNvPr id="4" name="PartsFlow"/>
+          <p:cNvPr id="4" name="Fundo da prévia"/>
           <p:cNvSpPr/>
           <p:nvPr/>
         </p:nvSpPr>
         <p:spPr>
           <a:xfrm>
-            <a:off x="4727448" y="3246120"/>
-            <a:ext cx="2743200" cy="1097280"/>
+            <a:off x="457200" y="1600200"/>
+            <a:ext cx="11247120" cy="4343400"/>
           </a:xfrm>
           <a:prstGeom prst="roundRect">
             <a:avLst>
-              <a:gd name="adj" fmla="val 12500"/>
+              <a:gd name="adj" fmla="val 2526"/>
             </a:avLst>
           </a:prstGeom>
           <a:solidFill>
-            <a:srgbClr val="13294B"/>
+            <a:srgbClr val="FFFFFF"/>
           </a:solidFill>
           <a:ln w="12700">
             <a:solidFill>
-              <a:srgbClr val="13294B"/>
-            </a:solidFill>
-            <a:prstDash val="solid"/>
-          </a:ln>
-        </p:spPr>
-      </p:sp>
-      <p:sp>
-        <p:nvSpPr>
-          <p:cNvPr id="5" name="Text 3"/>
-          <p:cNvSpPr txBox="1"/>
-          <p:nvPr/>
-        </p:nvSpPr>
-        <p:spPr>
-          <a:xfrm>
-            <a:off x="4727448" y="3246120"/>
-            <a:ext cx="2743200" cy="1097280"/>
-          </a:xfrm>
-          <a:prstGeom prst="rect">
-            <a:avLst/>
-          </a:prstGeom>
-          <a:noFill/>
-          <a:ln/>
-        </p:spPr>
-        <p:txBody>
-          <a:bodyPr wrap="square" lIns="0" tIns="0" rIns="0" bIns="0" rtlCol="0" anchor="ctr"/>
-          <a:lstStyle/>
-          <a:p>
-            <a:pPr algn="ctr" indent="0" marL="0">
-              <a:buNone/>
-            </a:pPr>
-            <a:r>
-              <a:rPr lang="en-US" sz="2600" b="1" dirty="0">
-                <a:solidFill>
-                  <a:srgbClr val="F4F1EA"/>
-                </a:solidFill>
-              </a:rPr>
-              <a:t>PartsFlow</a:t>
-            </a:r>
-            <a:endParaRPr lang="en-US" sz="2600" dirty="0"/>
-          </a:p>
-        </p:txBody>
-      </p:sp>
-      <p:sp>
-        <p:nvSpPr>
-          <p:cNvPr id="6" name="Cartão"/>
-          <p:cNvSpPr/>
-          <p:nvPr/>
-        </p:nvSpPr>
-        <p:spPr>
-          <a:xfrm>
-            <a:off x="548640" y="1783080"/>
-            <a:ext cx="3108960" cy="1325880"/>
-          </a:xfrm>
-          <a:prstGeom prst="roundRect">
-            <a:avLst>
-              <a:gd name="adj" fmla="val 8276"/>
-            </a:avLst>
-          </a:prstGeom>
-          <a:solidFill>
-            <a:srgbClr val="E9EEF5"/>
-          </a:solidFill>
-          <a:ln w="12700">
-            <a:solidFill>
-              <a:srgbClr val="E9EEF5"/>
+              <a:srgbClr val="FFFFFF"/>
             </a:solidFill>
             <a:prstDash val="solid"/>
           </a:ln>
@@ -6694,16 +6926,39 @@
           </a:effectLst>
         </p:spPr>
       </p:sp>
-      <p:sp>
-        <p:nvSpPr>
-          <p:cNvPr id="7" name="Text 5"/>
+      <p:pic>
+        <p:nvPicPr>
+          <p:cNvPr id="5" name="Captura" descr="Prévia do portal: o cliente digita código e quantidade; o vendedor recebe a cotação pronta">    </p:cNvPr>
+          <p:cNvPicPr>
+            <a:picLocks noChangeAspect="1"/>
+          </p:cNvPicPr>
+          <p:nvPr/>
+        </p:nvPicPr>
+        <p:blipFill>
+          <a:blip r:embed="rId1"/>
+          <a:srcRect l="0" r="0" t="0" b="0"/>
+          <a:stretch/>
+        </p:blipFill>
+        <p:spPr>
+          <a:xfrm>
+            <a:off x="548640" y="1673352"/>
+            <a:ext cx="11064240" cy="4160520"/>
+          </a:xfrm>
+          <a:prstGeom prst="rect">
+            <a:avLst/>
+          </a:prstGeom>
+        </p:spPr>
+      </p:pic>
+      <p:sp>
+        <p:nvSpPr>
+          <p:cNvPr id="6" name="Text 3"/>
           <p:cNvSpPr txBox="1"/>
           <p:nvPr/>
         </p:nvSpPr>
         <p:spPr>
           <a:xfrm>
-            <a:off x="777240" y="1920240"/>
-            <a:ext cx="2651760" cy="1051560"/>
+            <a:off x="548640" y="5989320"/>
+            <a:ext cx="11064240" cy="365760"/>
           </a:xfrm>
           <a:prstGeom prst="rect">
             <a:avLst/>
@@ -6719,406 +6974,12 @@
               <a:buNone/>
             </a:pPr>
             <a:r>
-              <a:rPr lang="en-US" sz="1800" b="1" dirty="0">
-                <a:solidFill>
-                  <a:srgbClr val="13294B"/>
-                </a:solidFill>
-              </a:rPr>
-              <a:t>JBoss / ERP</a:t>
-            </a:r>
-            <a:endParaRPr lang="en-US" sz="1800" dirty="0"/>
-          </a:p>
-          <a:p>
-            <a:pPr indent="0" marL="0">
-              <a:buNone/>
-            </a:pPr>
-            <a:r>
-              <a:rPr lang="en-US" sz="1400" dirty="0">
+              <a:rPr lang="en-US" sz="1400" i="1" dirty="0">
                 <a:solidFill>
                   <a:srgbClr val="3E4F66"/>
                 </a:solidFill>
               </a:rPr>
-              <a:t>Saldo, pedidos e preço entrando sozinhos</a:t>
-            </a:r>
-            <a:endParaRPr lang="en-US" sz="1800" dirty="0"/>
-          </a:p>
-        </p:txBody>
-      </p:sp>
-      <p:sp>
-        <p:nvSpPr>
-          <p:cNvPr id="8" name="Ligação"/>
-          <p:cNvSpPr/>
-          <p:nvPr/>
-        </p:nvSpPr>
-        <p:spPr>
-          <a:xfrm>
-            <a:off x="3657600" y="3108960"/>
-            <a:ext cx="1069848" cy="137160"/>
-          </a:xfrm>
-          <a:prstGeom prst="line">
-            <a:avLst/>
-          </a:prstGeom>
-          <a:noFill/>
-          <a:ln w="25400">
-            <a:solidFill>
-              <a:srgbClr val="C2591F"/>
-            </a:solidFill>
-            <a:prstDash val="dash"/>
-          </a:ln>
-        </p:spPr>
-      </p:sp>
-      <p:sp>
-        <p:nvSpPr>
-          <p:cNvPr id="9" name="Cartão"/>
-          <p:cNvSpPr/>
-          <p:nvPr/>
-        </p:nvSpPr>
-        <p:spPr>
-          <a:xfrm>
-            <a:off x="8549640" y="1783080"/>
-            <a:ext cx="3108960" cy="1325880"/>
-          </a:xfrm>
-          <a:prstGeom prst="roundRect">
-            <a:avLst>
-              <a:gd name="adj" fmla="val 8276"/>
-            </a:avLst>
-          </a:prstGeom>
-          <a:solidFill>
-            <a:srgbClr val="E9EEF5"/>
-          </a:solidFill>
-          <a:ln w="12700">
-            <a:solidFill>
-              <a:srgbClr val="E9EEF5"/>
-            </a:solidFill>
-            <a:prstDash val="solid"/>
-          </a:ln>
-          <a:effectLst>
-            <a:outerShdw sx="100000" sy="100000" kx="0" ky="0" algn="bl" rotWithShape="0" blurRad="76200" dist="25400" dir="5400000">
-              <a:srgbClr val="000000">
-                <a:alpha val="10000"/>
-              </a:srgbClr>
-            </a:outerShdw>
-          </a:effectLst>
-        </p:spPr>
-      </p:sp>
-      <p:sp>
-        <p:nvSpPr>
-          <p:cNvPr id="10" name="Text 8"/>
-          <p:cNvSpPr txBox="1"/>
-          <p:nvPr/>
-        </p:nvSpPr>
-        <p:spPr>
-          <a:xfrm>
-            <a:off x="8778240" y="1920240"/>
-            <a:ext cx="2651760" cy="1051560"/>
-          </a:xfrm>
-          <a:prstGeom prst="rect">
-            <a:avLst/>
-          </a:prstGeom>
-          <a:noFill/>
-          <a:ln/>
-        </p:spPr>
-        <p:txBody>
-          <a:bodyPr wrap="square" lIns="0" tIns="0" rIns="0" bIns="0" rtlCol="0" anchor="ctr"/>
-          <a:lstStyle/>
-          <a:p>
-            <a:pPr indent="0" marL="0">
-              <a:buNone/>
-            </a:pPr>
-            <a:r>
-              <a:rPr lang="en-US" sz="1800" b="1" dirty="0">
-                <a:solidFill>
-                  <a:srgbClr val="13294B"/>
-                </a:solidFill>
-              </a:rPr>
-              <a:t>Nosso site de vendas</a:t>
-            </a:r>
-            <a:endParaRPr lang="en-US" sz="1800" dirty="0"/>
-          </a:p>
-          <a:p>
-            <a:pPr indent="0" marL="0">
-              <a:buNone/>
-            </a:pPr>
-            <a:r>
-              <a:rPr lang="en-US" sz="1400" dirty="0">
-                <a:solidFill>
-                  <a:srgbClr val="3E4F66"/>
-                </a:solidFill>
-              </a:rPr>
-              <a:t>Mesmo cadastro, aplicação e foto</a:t>
-            </a:r>
-            <a:endParaRPr lang="en-US" sz="1800" dirty="0"/>
-          </a:p>
-        </p:txBody>
-      </p:sp>
-      <p:sp>
-        <p:nvSpPr>
-          <p:cNvPr id="11" name="Ligação"/>
-          <p:cNvSpPr/>
-          <p:nvPr/>
-        </p:nvSpPr>
-        <p:spPr>
-          <a:xfrm flipV="1">
-            <a:off x="7470648" y="3108960"/>
-            <a:ext cx="1078992" cy="137160"/>
-          </a:xfrm>
-          <a:prstGeom prst="line">
-            <a:avLst/>
-          </a:prstGeom>
-          <a:noFill/>
-          <a:ln w="25400">
-            <a:solidFill>
-              <a:srgbClr val="C2591F"/>
-            </a:solidFill>
-            <a:prstDash val="dash"/>
-          </a:ln>
-        </p:spPr>
-      </p:sp>
-      <p:sp>
-        <p:nvSpPr>
-          <p:cNvPr id="12" name="Cartão"/>
-          <p:cNvSpPr/>
-          <p:nvPr/>
-        </p:nvSpPr>
-        <p:spPr>
-          <a:xfrm>
-            <a:off x="548640" y="4572000"/>
-            <a:ext cx="3108960" cy="1325880"/>
-          </a:xfrm>
-          <a:prstGeom prst="roundRect">
-            <a:avLst>
-              <a:gd name="adj" fmla="val 8276"/>
-            </a:avLst>
-          </a:prstGeom>
-          <a:solidFill>
-            <a:srgbClr val="E9EEF5"/>
-          </a:solidFill>
-          <a:ln w="12700">
-            <a:solidFill>
-              <a:srgbClr val="E9EEF5"/>
-            </a:solidFill>
-            <a:prstDash val="solid"/>
-          </a:ln>
-          <a:effectLst>
-            <a:outerShdw sx="100000" sy="100000" kx="0" ky="0" algn="bl" rotWithShape="0" blurRad="76200" dist="25400" dir="5400000">
-              <a:srgbClr val="000000">
-                <a:alpha val="10000"/>
-              </a:srgbClr>
-            </a:outerShdw>
-          </a:effectLst>
-        </p:spPr>
-      </p:sp>
-      <p:sp>
-        <p:nvSpPr>
-          <p:cNvPr id="13" name="Text 11"/>
-          <p:cNvSpPr txBox="1"/>
-          <p:nvPr/>
-        </p:nvSpPr>
-        <p:spPr>
-          <a:xfrm>
-            <a:off x="777240" y="4709160"/>
-            <a:ext cx="2651760" cy="1051560"/>
-          </a:xfrm>
-          <a:prstGeom prst="rect">
-            <a:avLst/>
-          </a:prstGeom>
-          <a:noFill/>
-          <a:ln/>
-        </p:spPr>
-        <p:txBody>
-          <a:bodyPr wrap="square" lIns="0" tIns="0" rIns="0" bIns="0" rtlCol="0" anchor="ctr"/>
-          <a:lstStyle/>
-          <a:p>
-            <a:pPr indent="0" marL="0">
-              <a:buNone/>
-            </a:pPr>
-            <a:r>
-              <a:rPr lang="en-US" sz="1800" b="1" dirty="0">
-                <a:solidFill>
-                  <a:srgbClr val="13294B"/>
-                </a:solidFill>
-              </a:rPr>
-              <a:t>Vendas On e marketplaces</a:t>
-            </a:r>
-            <a:endParaRPr lang="en-US" sz="1800" dirty="0"/>
-          </a:p>
-          <a:p>
-            <a:pPr indent="0" marL="0">
-              <a:buNone/>
-            </a:pPr>
-            <a:r>
-              <a:rPr lang="en-US" sz="1400" dirty="0">
-                <a:solidFill>
-                  <a:srgbClr val="3E4F66"/>
-                </a:solidFill>
-              </a:rPr>
-              <a:t>Anúncio e pedido sem redigitar</a:t>
-            </a:r>
-            <a:endParaRPr lang="en-US" sz="1800" dirty="0"/>
-          </a:p>
-        </p:txBody>
-      </p:sp>
-      <p:sp>
-        <p:nvSpPr>
-          <p:cNvPr id="14" name="Ligação"/>
-          <p:cNvSpPr/>
-          <p:nvPr/>
-        </p:nvSpPr>
-        <p:spPr>
-          <a:xfrm flipV="1">
-            <a:off x="3657600" y="4343400"/>
-            <a:ext cx="1069848" cy="228600"/>
-          </a:xfrm>
-          <a:prstGeom prst="line">
-            <a:avLst/>
-          </a:prstGeom>
-          <a:noFill/>
-          <a:ln w="25400">
-            <a:solidFill>
-              <a:srgbClr val="C2591F"/>
-            </a:solidFill>
-            <a:prstDash val="dash"/>
-          </a:ln>
-        </p:spPr>
-      </p:sp>
-      <p:sp>
-        <p:nvSpPr>
-          <p:cNvPr id="15" name="Cartão"/>
-          <p:cNvSpPr/>
-          <p:nvPr/>
-        </p:nvSpPr>
-        <p:spPr>
-          <a:xfrm>
-            <a:off x="8549640" y="4572000"/>
-            <a:ext cx="3108960" cy="1325880"/>
-          </a:xfrm>
-          <a:prstGeom prst="roundRect">
-            <a:avLst>
-              <a:gd name="adj" fmla="val 8276"/>
-            </a:avLst>
-          </a:prstGeom>
-          <a:solidFill>
-            <a:srgbClr val="E9EEF5"/>
-          </a:solidFill>
-          <a:ln w="12700">
-            <a:solidFill>
-              <a:srgbClr val="E9EEF5"/>
-            </a:solidFill>
-            <a:prstDash val="solid"/>
-          </a:ln>
-          <a:effectLst>
-            <a:outerShdw sx="100000" sy="100000" kx="0" ky="0" algn="bl" rotWithShape="0" blurRad="76200" dist="25400" dir="5400000">
-              <a:srgbClr val="000000">
-                <a:alpha val="10000"/>
-              </a:srgbClr>
-            </a:outerShdw>
-          </a:effectLst>
-        </p:spPr>
-      </p:sp>
-      <p:sp>
-        <p:nvSpPr>
-          <p:cNvPr id="16" name="Text 14"/>
-          <p:cNvSpPr txBox="1"/>
-          <p:nvPr/>
-        </p:nvSpPr>
-        <p:spPr>
-          <a:xfrm>
-            <a:off x="8778240" y="4709160"/>
-            <a:ext cx="2651760" cy="1051560"/>
-          </a:xfrm>
-          <a:prstGeom prst="rect">
-            <a:avLst/>
-          </a:prstGeom>
-          <a:noFill/>
-          <a:ln/>
-        </p:spPr>
-        <p:txBody>
-          <a:bodyPr wrap="square" lIns="0" tIns="0" rIns="0" bIns="0" rtlCol="0" anchor="ctr"/>
-          <a:lstStyle/>
-          <a:p>
-            <a:pPr indent="0" marL="0">
-              <a:buNone/>
-            </a:pPr>
-            <a:r>
-              <a:rPr lang="en-US" sz="1800" b="1" dirty="0">
-                <a:solidFill>
-                  <a:srgbClr val="13294B"/>
-                </a:solidFill>
-              </a:rPr>
-              <a:t>WhatsApp oficial</a:t>
-            </a:r>
-            <a:endParaRPr lang="en-US" sz="1800" dirty="0"/>
-          </a:p>
-          <a:p>
-            <a:pPr indent="0" marL="0">
-              <a:buNone/>
-            </a:pPr>
-            <a:r>
-              <a:rPr lang="en-US" sz="1400" dirty="0">
-                <a:solidFill>
-                  <a:srgbClr val="3E4F66"/>
-                </a:solidFill>
-              </a:rPr>
-              <a:t>Avisar pedido emitido e faturado</a:t>
-            </a:r>
-            <a:endParaRPr lang="en-US" sz="1800" dirty="0"/>
-          </a:p>
-        </p:txBody>
-      </p:sp>
-      <p:sp>
-        <p:nvSpPr>
-          <p:cNvPr id="17" name="Ligação"/>
-          <p:cNvSpPr/>
-          <p:nvPr/>
-        </p:nvSpPr>
-        <p:spPr>
-          <a:xfrm>
-            <a:off x="7470648" y="4343400"/>
-            <a:ext cx="1078992" cy="228600"/>
-          </a:xfrm>
-          <a:prstGeom prst="line">
-            <a:avLst/>
-          </a:prstGeom>
-          <a:noFill/>
-          <a:ln w="25400">
-            <a:solidFill>
-              <a:srgbClr val="C2591F"/>
-            </a:solidFill>
-            <a:prstDash val="dash"/>
-          </a:ln>
-        </p:spPr>
-      </p:sp>
-      <p:sp>
-        <p:nvSpPr>
-          <p:cNvPr id="18" name="Text 16"/>
-          <p:cNvSpPr txBox="1"/>
-          <p:nvPr/>
-        </p:nvSpPr>
-        <p:spPr>
-          <a:xfrm>
-            <a:off x="548640" y="5989320"/>
-            <a:ext cx="11064240" cy="365760"/>
-          </a:xfrm>
-          <a:prstGeom prst="rect">
-            <a:avLst/>
-          </a:prstGeom>
-          <a:noFill/>
-          <a:ln/>
-        </p:spPr>
-        <p:txBody>
-          <a:bodyPr wrap="square" lIns="0" tIns="0" rIns="0" bIns="0" rtlCol="0" anchor="ctr"/>
-          <a:lstStyle/>
-          <a:p>
-            <a:pPr indent="0" marL="0">
-              <a:buNone/>
-            </a:pPr>
-            <a:r>
-              <a:rPr lang="en-US" sz="1400" i="1" dirty="0">
-                <a:solidFill>
-                  <a:srgbClr val="3E4F66"/>
-                </a:solidFill>
-              </a:rPr>
-              <a:t>Portal do cliente (próximo passo): com login, ele cota sozinho digitando só código e quantidade.</a:t>
+              <a:t>Código de qualquer marca (Spicer, REI, Stahl, original) · preço da tabela dele · o que não sair sozinho vai pro vendedor</a:t>
             </a:r>
             <a:endParaRPr lang="en-US" sz="1400" dirty="0"/>
           </a:p>
@@ -7196,7 +7057,43 @@
       </p:grpSpPr>
       <p:sp>
         <p:nvSpPr>
-          <p:cNvPr id="2" name="Text 0"/>
+          <p:cNvPr id="2" name="Chamada"/>
+          <p:cNvSpPr txBox="1"/>
+          <p:nvPr/>
+        </p:nvSpPr>
+        <p:spPr>
+          <a:xfrm>
+            <a:off x="548640" y="365760"/>
+            <a:ext cx="8229600" cy="365760"/>
+          </a:xfrm>
+          <a:prstGeom prst="rect">
+            <a:avLst/>
+          </a:prstGeom>
+          <a:noFill/>
+          <a:ln/>
+        </p:spPr>
+        <p:txBody>
+          <a:bodyPr wrap="square" lIns="0" tIns="0" rIns="0" bIns="0" rtlCol="0" anchor="ctr"/>
+          <a:lstStyle/>
+          <a:p>
+            <a:pPr indent="0" marL="0">
+              <a:buNone/>
+            </a:pPr>
+            <a:r>
+              <a:rPr lang="en-US" sz="1400" b="1" spc="300" kern="0" dirty="0">
+                <a:solidFill>
+                  <a:schemeClr val="accent1"/>
+                </a:solidFill>
+              </a:rPr>
+              <a:t>DAQUI PRA FRENTE</a:t>
+            </a:r>
+            <a:endParaRPr lang="en-US" sz="1400" dirty="0"/>
+          </a:p>
+        </p:txBody>
+      </p:sp>
+      <p:sp>
+        <p:nvSpPr>
+          <p:cNvPr id="3" name="Text 0"/>
           <p:cNvSpPr/>
           <p:nvPr>
             <p:ph idx="100" type="title" hasCustomPrompt="1"/>
@@ -7204,8 +7101,8 @@
         </p:nvSpPr>
         <p:spPr>
           <a:xfrm>
-            <a:off x="731520" y="1828800"/>
-            <a:ext cx="10607040" cy="2103120"/>
+            <a:off x="548640" y="777240"/>
+            <a:ext cx="11064240" cy="822960"/>
           </a:xfrm>
           <a:prstGeom prst="rect">
             <a:avLst/>
@@ -7221,28 +7118,647 @@
               <a:buNone/>
             </a:pPr>
             <a:r>
-              <a:rPr lang="en-US" sz="5200" b="1" dirty="0">
-                <a:solidFill>
-                  <a:schemeClr val="accent4"/>
-                </a:solidFill>
-              </a:rPr>
-              <a:t>Piloto de 30 dias.</a:t>
-            </a:r>
-            <a:endParaRPr lang="en-US" sz="5200" dirty="0"/>
-          </a:p>
-          <a:p>
-            <a:pPr algn="l" indent="0" marL="0">
+              <a:rPr lang="en-US" sz="3000" b="1" dirty="0">
+                <a:solidFill>
+                  <a:schemeClr val="tx1"/>
+                </a:solidFill>
+              </a:rPr>
+              <a:t>Hoje ao lado do JBoss. Amanhã, integrado.</a:t>
+            </a:r>
+            <a:endParaRPr lang="en-US" sz="3000" dirty="0"/>
+          </a:p>
+        </p:txBody>
+      </p:sp>
+      <p:sp>
+        <p:nvSpPr>
+          <p:cNvPr id="4" name="PartsFlow"/>
+          <p:cNvSpPr/>
+          <p:nvPr/>
+        </p:nvSpPr>
+        <p:spPr>
+          <a:xfrm>
+            <a:off x="4727448" y="3246120"/>
+            <a:ext cx="2743200" cy="1097280"/>
+          </a:xfrm>
+          <a:prstGeom prst="roundRect">
+            <a:avLst>
+              <a:gd name="adj" fmla="val 12500"/>
+            </a:avLst>
+          </a:prstGeom>
+          <a:solidFill>
+            <a:srgbClr val="13294B"/>
+          </a:solidFill>
+          <a:ln w="12700">
+            <a:solidFill>
+              <a:srgbClr val="13294B"/>
+            </a:solidFill>
+            <a:prstDash val="solid"/>
+          </a:ln>
+        </p:spPr>
+      </p:sp>
+      <p:sp>
+        <p:nvSpPr>
+          <p:cNvPr id="5" name="Text 3"/>
+          <p:cNvSpPr txBox="1"/>
+          <p:nvPr/>
+        </p:nvSpPr>
+        <p:spPr>
+          <a:xfrm>
+            <a:off x="4727448" y="3246120"/>
+            <a:ext cx="2743200" cy="1097280"/>
+          </a:xfrm>
+          <a:prstGeom prst="rect">
+            <a:avLst/>
+          </a:prstGeom>
+          <a:noFill/>
+          <a:ln/>
+        </p:spPr>
+        <p:txBody>
+          <a:bodyPr wrap="square" lIns="0" tIns="0" rIns="0" bIns="0" rtlCol="0" anchor="ctr"/>
+          <a:lstStyle/>
+          <a:p>
+            <a:pPr algn="ctr" indent="0" marL="0">
               <a:buNone/>
             </a:pPr>
             <a:r>
-              <a:rPr lang="en-US" sz="5200" b="1" dirty="0">
-                <a:solidFill>
-                  <a:schemeClr val="accent2"/>
-                </a:solidFill>
-              </a:rPr>
-              <a:t>Sem mexer no ERP.</a:t>
-            </a:r>
-            <a:endParaRPr lang="en-US" sz="5200" dirty="0"/>
+              <a:rPr lang="en-US" sz="2600" b="1" dirty="0">
+                <a:solidFill>
+                  <a:srgbClr val="F4F1EA"/>
+                </a:solidFill>
+              </a:rPr>
+              <a:t>PartsFlow</a:t>
+            </a:r>
+            <a:endParaRPr lang="en-US" sz="2600" dirty="0"/>
+          </a:p>
+        </p:txBody>
+      </p:sp>
+      <p:sp>
+        <p:nvSpPr>
+          <p:cNvPr id="6" name="Cartão"/>
+          <p:cNvSpPr/>
+          <p:nvPr/>
+        </p:nvSpPr>
+        <p:spPr>
+          <a:xfrm>
+            <a:off x="548640" y="1783080"/>
+            <a:ext cx="3108960" cy="1325880"/>
+          </a:xfrm>
+          <a:prstGeom prst="roundRect">
+            <a:avLst>
+              <a:gd name="adj" fmla="val 8276"/>
+            </a:avLst>
+          </a:prstGeom>
+          <a:solidFill>
+            <a:srgbClr val="E9EEF5"/>
+          </a:solidFill>
+          <a:ln w="12700">
+            <a:solidFill>
+              <a:srgbClr val="E9EEF5"/>
+            </a:solidFill>
+            <a:prstDash val="solid"/>
+          </a:ln>
+          <a:effectLst>
+            <a:outerShdw sx="100000" sy="100000" kx="0" ky="0" algn="bl" rotWithShape="0" blurRad="76200" dist="25400" dir="5400000">
+              <a:srgbClr val="000000">
+                <a:alpha val="10000"/>
+              </a:srgbClr>
+            </a:outerShdw>
+          </a:effectLst>
+        </p:spPr>
+      </p:sp>
+      <p:sp>
+        <p:nvSpPr>
+          <p:cNvPr id="7" name="Text 5"/>
+          <p:cNvSpPr txBox="1"/>
+          <p:nvPr/>
+        </p:nvSpPr>
+        <p:spPr>
+          <a:xfrm>
+            <a:off x="777240" y="1920240"/>
+            <a:ext cx="2651760" cy="1051560"/>
+          </a:xfrm>
+          <a:prstGeom prst="rect">
+            <a:avLst/>
+          </a:prstGeom>
+          <a:noFill/>
+          <a:ln/>
+        </p:spPr>
+        <p:txBody>
+          <a:bodyPr wrap="square" lIns="0" tIns="0" rIns="0" bIns="0" rtlCol="0" anchor="ctr"/>
+          <a:lstStyle/>
+          <a:p>
+            <a:pPr indent="0" marL="0">
+              <a:buNone/>
+            </a:pPr>
+            <a:r>
+              <a:rPr lang="en-US" sz="1800" b="1" dirty="0">
+                <a:solidFill>
+                  <a:srgbClr val="13294B"/>
+                </a:solidFill>
+              </a:rPr>
+              <a:t>JBoss / ERP</a:t>
+            </a:r>
+            <a:endParaRPr lang="en-US" sz="1800" dirty="0"/>
+          </a:p>
+          <a:p>
+            <a:pPr indent="0" marL="0">
+              <a:buNone/>
+            </a:pPr>
+            <a:r>
+              <a:rPr lang="en-US" sz="1400" dirty="0">
+                <a:solidFill>
+                  <a:srgbClr val="3E4F66"/>
+                </a:solidFill>
+              </a:rPr>
+              <a:t>Saldo, pedidos e preço entrando sozinhos</a:t>
+            </a:r>
+            <a:endParaRPr lang="en-US" sz="1800" dirty="0"/>
+          </a:p>
+        </p:txBody>
+      </p:sp>
+      <p:sp>
+        <p:nvSpPr>
+          <p:cNvPr id="8" name="Ligação"/>
+          <p:cNvSpPr/>
+          <p:nvPr/>
+        </p:nvSpPr>
+        <p:spPr>
+          <a:xfrm>
+            <a:off x="3657600" y="3108960"/>
+            <a:ext cx="1069848" cy="137160"/>
+          </a:xfrm>
+          <a:prstGeom prst="line">
+            <a:avLst/>
+          </a:prstGeom>
+          <a:noFill/>
+          <a:ln w="25400">
+            <a:solidFill>
+              <a:srgbClr val="C2591F"/>
+            </a:solidFill>
+            <a:prstDash val="dash"/>
+          </a:ln>
+        </p:spPr>
+      </p:sp>
+      <p:sp>
+        <p:nvSpPr>
+          <p:cNvPr id="9" name="Cartão"/>
+          <p:cNvSpPr/>
+          <p:nvPr/>
+        </p:nvSpPr>
+        <p:spPr>
+          <a:xfrm>
+            <a:off x="8549640" y="1783080"/>
+            <a:ext cx="3108960" cy="1325880"/>
+          </a:xfrm>
+          <a:prstGeom prst="roundRect">
+            <a:avLst>
+              <a:gd name="adj" fmla="val 8276"/>
+            </a:avLst>
+          </a:prstGeom>
+          <a:solidFill>
+            <a:srgbClr val="E9EEF5"/>
+          </a:solidFill>
+          <a:ln w="12700">
+            <a:solidFill>
+              <a:srgbClr val="E9EEF5"/>
+            </a:solidFill>
+            <a:prstDash val="solid"/>
+          </a:ln>
+          <a:effectLst>
+            <a:outerShdw sx="100000" sy="100000" kx="0" ky="0" algn="bl" rotWithShape="0" blurRad="76200" dist="25400" dir="5400000">
+              <a:srgbClr val="000000">
+                <a:alpha val="10000"/>
+              </a:srgbClr>
+            </a:outerShdw>
+          </a:effectLst>
+        </p:spPr>
+      </p:sp>
+      <p:sp>
+        <p:nvSpPr>
+          <p:cNvPr id="10" name="Text 8"/>
+          <p:cNvSpPr txBox="1"/>
+          <p:nvPr/>
+        </p:nvSpPr>
+        <p:spPr>
+          <a:xfrm>
+            <a:off x="8778240" y="1920240"/>
+            <a:ext cx="2651760" cy="1051560"/>
+          </a:xfrm>
+          <a:prstGeom prst="rect">
+            <a:avLst/>
+          </a:prstGeom>
+          <a:noFill/>
+          <a:ln/>
+        </p:spPr>
+        <p:txBody>
+          <a:bodyPr wrap="square" lIns="0" tIns="0" rIns="0" bIns="0" rtlCol="0" anchor="ctr"/>
+          <a:lstStyle/>
+          <a:p>
+            <a:pPr indent="0" marL="0">
+              <a:buNone/>
+            </a:pPr>
+            <a:r>
+              <a:rPr lang="en-US" sz="1800" b="1" dirty="0">
+                <a:solidFill>
+                  <a:srgbClr val="13294B"/>
+                </a:solidFill>
+              </a:rPr>
+              <a:t>Nosso site de vendas</a:t>
+            </a:r>
+            <a:endParaRPr lang="en-US" sz="1800" dirty="0"/>
+          </a:p>
+          <a:p>
+            <a:pPr indent="0" marL="0">
+              <a:buNone/>
+            </a:pPr>
+            <a:r>
+              <a:rPr lang="en-US" sz="1400" dirty="0">
+                <a:solidFill>
+                  <a:srgbClr val="3E4F66"/>
+                </a:solidFill>
+              </a:rPr>
+              <a:t>Mesmo cadastro, aplicação e foto</a:t>
+            </a:r>
+            <a:endParaRPr lang="en-US" sz="1800" dirty="0"/>
+          </a:p>
+        </p:txBody>
+      </p:sp>
+      <p:sp>
+        <p:nvSpPr>
+          <p:cNvPr id="11" name="Ligação"/>
+          <p:cNvSpPr/>
+          <p:nvPr/>
+        </p:nvSpPr>
+        <p:spPr>
+          <a:xfrm flipV="1">
+            <a:off x="7470648" y="3108960"/>
+            <a:ext cx="1078992" cy="137160"/>
+          </a:xfrm>
+          <a:prstGeom prst="line">
+            <a:avLst/>
+          </a:prstGeom>
+          <a:noFill/>
+          <a:ln w="25400">
+            <a:solidFill>
+              <a:srgbClr val="C2591F"/>
+            </a:solidFill>
+            <a:prstDash val="dash"/>
+          </a:ln>
+        </p:spPr>
+      </p:sp>
+      <p:sp>
+        <p:nvSpPr>
+          <p:cNvPr id="12" name="Cartão"/>
+          <p:cNvSpPr/>
+          <p:nvPr/>
+        </p:nvSpPr>
+        <p:spPr>
+          <a:xfrm>
+            <a:off x="548640" y="4572000"/>
+            <a:ext cx="3108960" cy="1325880"/>
+          </a:xfrm>
+          <a:prstGeom prst="roundRect">
+            <a:avLst>
+              <a:gd name="adj" fmla="val 8276"/>
+            </a:avLst>
+          </a:prstGeom>
+          <a:solidFill>
+            <a:srgbClr val="E9EEF5"/>
+          </a:solidFill>
+          <a:ln w="12700">
+            <a:solidFill>
+              <a:srgbClr val="E9EEF5"/>
+            </a:solidFill>
+            <a:prstDash val="solid"/>
+          </a:ln>
+          <a:effectLst>
+            <a:outerShdw sx="100000" sy="100000" kx="0" ky="0" algn="bl" rotWithShape="0" blurRad="76200" dist="25400" dir="5400000">
+              <a:srgbClr val="000000">
+                <a:alpha val="10000"/>
+              </a:srgbClr>
+            </a:outerShdw>
+          </a:effectLst>
+        </p:spPr>
+      </p:sp>
+      <p:sp>
+        <p:nvSpPr>
+          <p:cNvPr id="13" name="Text 11"/>
+          <p:cNvSpPr txBox="1"/>
+          <p:nvPr/>
+        </p:nvSpPr>
+        <p:spPr>
+          <a:xfrm>
+            <a:off x="777240" y="4709160"/>
+            <a:ext cx="2651760" cy="1051560"/>
+          </a:xfrm>
+          <a:prstGeom prst="rect">
+            <a:avLst/>
+          </a:prstGeom>
+          <a:noFill/>
+          <a:ln/>
+        </p:spPr>
+        <p:txBody>
+          <a:bodyPr wrap="square" lIns="0" tIns="0" rIns="0" bIns="0" rtlCol="0" anchor="ctr"/>
+          <a:lstStyle/>
+          <a:p>
+            <a:pPr indent="0" marL="0">
+              <a:buNone/>
+            </a:pPr>
+            <a:r>
+              <a:rPr lang="en-US" sz="1800" b="1" dirty="0">
+                <a:solidFill>
+                  <a:srgbClr val="13294B"/>
+                </a:solidFill>
+              </a:rPr>
+              <a:t>Vendas On e marketplaces</a:t>
+            </a:r>
+            <a:endParaRPr lang="en-US" sz="1800" dirty="0"/>
+          </a:p>
+          <a:p>
+            <a:pPr indent="0" marL="0">
+              <a:buNone/>
+            </a:pPr>
+            <a:r>
+              <a:rPr lang="en-US" sz="1400" dirty="0">
+                <a:solidFill>
+                  <a:srgbClr val="3E4F66"/>
+                </a:solidFill>
+              </a:rPr>
+              <a:t>Anúncio e pedido sem redigitar</a:t>
+            </a:r>
+            <a:endParaRPr lang="en-US" sz="1800" dirty="0"/>
+          </a:p>
+        </p:txBody>
+      </p:sp>
+      <p:sp>
+        <p:nvSpPr>
+          <p:cNvPr id="14" name="Ligação"/>
+          <p:cNvSpPr/>
+          <p:nvPr/>
+        </p:nvSpPr>
+        <p:spPr>
+          <a:xfrm flipV="1">
+            <a:off x="3657600" y="4343400"/>
+            <a:ext cx="1069848" cy="228600"/>
+          </a:xfrm>
+          <a:prstGeom prst="line">
+            <a:avLst/>
+          </a:prstGeom>
+          <a:noFill/>
+          <a:ln w="25400">
+            <a:solidFill>
+              <a:srgbClr val="C2591F"/>
+            </a:solidFill>
+            <a:prstDash val="dash"/>
+          </a:ln>
+        </p:spPr>
+      </p:sp>
+      <p:sp>
+        <p:nvSpPr>
+          <p:cNvPr id="15" name="Cartão"/>
+          <p:cNvSpPr/>
+          <p:nvPr/>
+        </p:nvSpPr>
+        <p:spPr>
+          <a:xfrm>
+            <a:off x="8549640" y="4572000"/>
+            <a:ext cx="3108960" cy="1325880"/>
+          </a:xfrm>
+          <a:prstGeom prst="roundRect">
+            <a:avLst>
+              <a:gd name="adj" fmla="val 8276"/>
+            </a:avLst>
+          </a:prstGeom>
+          <a:solidFill>
+            <a:srgbClr val="E9EEF5"/>
+          </a:solidFill>
+          <a:ln w="12700">
+            <a:solidFill>
+              <a:srgbClr val="E9EEF5"/>
+            </a:solidFill>
+            <a:prstDash val="solid"/>
+          </a:ln>
+          <a:effectLst>
+            <a:outerShdw sx="100000" sy="100000" kx="0" ky="0" algn="bl" rotWithShape="0" blurRad="76200" dist="25400" dir="5400000">
+              <a:srgbClr val="000000">
+                <a:alpha val="10000"/>
+              </a:srgbClr>
+            </a:outerShdw>
+          </a:effectLst>
+        </p:spPr>
+      </p:sp>
+      <p:sp>
+        <p:nvSpPr>
+          <p:cNvPr id="16" name="Text 14"/>
+          <p:cNvSpPr txBox="1"/>
+          <p:nvPr/>
+        </p:nvSpPr>
+        <p:spPr>
+          <a:xfrm>
+            <a:off x="8778240" y="4709160"/>
+            <a:ext cx="2651760" cy="1051560"/>
+          </a:xfrm>
+          <a:prstGeom prst="rect">
+            <a:avLst/>
+          </a:prstGeom>
+          <a:noFill/>
+          <a:ln/>
+        </p:spPr>
+        <p:txBody>
+          <a:bodyPr wrap="square" lIns="0" tIns="0" rIns="0" bIns="0" rtlCol="0" anchor="ctr"/>
+          <a:lstStyle/>
+          <a:p>
+            <a:pPr indent="0" marL="0">
+              <a:buNone/>
+            </a:pPr>
+            <a:r>
+              <a:rPr lang="en-US" sz="1800" b="1" dirty="0">
+                <a:solidFill>
+                  <a:srgbClr val="13294B"/>
+                </a:solidFill>
+              </a:rPr>
+              <a:t>WhatsApp oficial</a:t>
+            </a:r>
+            <a:endParaRPr lang="en-US" sz="1800" dirty="0"/>
+          </a:p>
+          <a:p>
+            <a:pPr indent="0" marL="0">
+              <a:buNone/>
+            </a:pPr>
+            <a:r>
+              <a:rPr lang="en-US" sz="1400" dirty="0">
+                <a:solidFill>
+                  <a:srgbClr val="3E4F66"/>
+                </a:solidFill>
+              </a:rPr>
+              <a:t>Avisar pedido emitido e faturado</a:t>
+            </a:r>
+            <a:endParaRPr lang="en-US" sz="1800" dirty="0"/>
+          </a:p>
+        </p:txBody>
+      </p:sp>
+      <p:sp>
+        <p:nvSpPr>
+          <p:cNvPr id="17" name="Ligação"/>
+          <p:cNvSpPr/>
+          <p:nvPr/>
+        </p:nvSpPr>
+        <p:spPr>
+          <a:xfrm>
+            <a:off x="7470648" y="4343400"/>
+            <a:ext cx="1078992" cy="228600"/>
+          </a:xfrm>
+          <a:prstGeom prst="line">
+            <a:avLst/>
+          </a:prstGeom>
+          <a:noFill/>
+          <a:ln w="25400">
+            <a:solidFill>
+              <a:srgbClr val="C2591F"/>
+            </a:solidFill>
+            <a:prstDash val="dash"/>
+          </a:ln>
+        </p:spPr>
+      </p:sp>
+      <p:sp>
+        <p:nvSpPr>
+          <p:cNvPr id="18" name="Text 16"/>
+          <p:cNvSpPr txBox="1"/>
+          <p:nvPr/>
+        </p:nvSpPr>
+        <p:spPr>
+          <a:xfrm>
+            <a:off x="548640" y="5989320"/>
+            <a:ext cx="11064240" cy="365760"/>
+          </a:xfrm>
+          <a:prstGeom prst="rect">
+            <a:avLst/>
+          </a:prstGeom>
+          <a:noFill/>
+          <a:ln/>
+        </p:spPr>
+        <p:txBody>
+          <a:bodyPr wrap="square" lIns="0" tIns="0" rIns="0" bIns="0" rtlCol="0" anchor="ctr"/>
+          <a:lstStyle/>
+          <a:p>
+            <a:pPr indent="0" marL="0">
+              <a:buNone/>
+            </a:pPr>
+            <a:r>
+              <a:rPr lang="en-US" sz="1400" i="1" dirty="0">
+                <a:solidFill>
+                  <a:srgbClr val="3E4F66"/>
+                </a:solidFill>
+              </a:rPr>
+              <a:t>Portal do cliente (próximo passo): com login, ele cota sozinho digitando só código e quantidade.</a:t>
+            </a:r>
+            <a:endParaRPr lang="en-US" sz="1400" dirty="0"/>
+          </a:p>
+        </p:txBody>
+      </p:sp>
+      <p:sp>
+        <p:nvSpPr>
+          <p:cNvPr id="25" name="Slide Number Placeholder 0"/>
+          <p:cNvSpPr>
+            <a:spLocks noGrp="1"/>
+          </p:cNvSpPr>
+          <p:nvPr>
+            <p:ph type="sldNum" sz="quarter" idx="4294967295"/>
+          </p:nvPr>
+        </p:nvSpPr>
+        <p:spPr>
+          <a:xfrm>
+            <a:off x="11064240" y="6382512"/>
+            <a:ext cx="640080" cy="274320"/>
+          </a:xfrm>
+          <a:prstGeom prst="rect">
+            <a:avLst/>
+          </a:prstGeom>
+          <a:extLst>
+            <a:ext uri="{C572A759-6A51-4108-AA02-DFA0A04FC94B}">
+              <ma14:wrappingTextBoxFlag xmlns:ma14="http://schemas.microsoft.com/office/mac/drawingml/2011/main" val="0"/>
+            </a:ext>
+          </a:extLst>
+        </p:spPr>
+        <p:txBody>
+          <a:bodyPr/>
+          <a:lstStyle>
+            <a:lvl1pPr>
+              <a:defRPr sz="1100">
+                <a:solidFill>
+                  <a:srgbClr val="6B7A90"/>
+                </a:solidFill>
+              </a:defRPr>
+            </a:lvl1pPr>
+          </a:lstStyle>
+          <a:p>
+            <a:pPr algn="r"/>
+            <a:fld id="{F7021451-1387-4CA6-816F-3879F97B5CBC}" type="slidenum">
+              <a:rPr b="0" lang="en-US"/>
+              <a:t>8</a:t>
+            </a:fld>
+            <a:endParaRPr lang="en-US"/>
+          </a:p>
+        </p:txBody>
+      </p:sp>
+    </p:spTree>
+  </p:cSld>
+  <p:clrMapOvr>
+    <a:masterClrMapping/>
+  </p:clrMapOvr>
+</p:sld>
+</file>
+
+<file path=ppt/slides/slide9.xml><?xml version="1.0" encoding="utf-8"?>
+<p:sld xmlns:a="http://schemas.openxmlformats.org/drawingml/2006/main" xmlns:r="http://schemas.openxmlformats.org/officeDocument/2006/relationships" xmlns:p="http://schemas.openxmlformats.org/presentationml/2006/main">
+  <p:cSld name="Slide 9">
+    <p:spTree>
+      <p:nvGrpSpPr>
+        <p:cNvPr id="1" name=""/>
+        <p:cNvGrpSpPr/>
+        <p:nvPr/>
+      </p:nvGrpSpPr>
+      <p:grpSpPr>
+        <a:xfrm>
+          <a:off x="0" y="0"/>
+          <a:ext cx="0" cy="0"/>
+          <a:chOff x="0" y="0"/>
+          <a:chExt cx="0" cy="0"/>
+        </a:xfrm>
+      </p:grpSpPr>
+      <p:sp>
+        <p:nvSpPr>
+          <p:cNvPr id="2" name="Chamada"/>
+          <p:cNvSpPr txBox="1"/>
+          <p:nvPr/>
+        </p:nvSpPr>
+        <p:spPr>
+          <a:xfrm>
+            <a:off x="548640" y="365760"/>
+            <a:ext cx="8229600" cy="365760"/>
+          </a:xfrm>
+          <a:prstGeom prst="rect">
+            <a:avLst/>
+          </a:prstGeom>
+          <a:noFill/>
+          <a:ln/>
+        </p:spPr>
+        <p:txBody>
+          <a:bodyPr wrap="square" lIns="0" tIns="0" rIns="0" bIns="0" rtlCol="0" anchor="ctr"/>
+          <a:lstStyle/>
+          <a:p>
+            <a:pPr indent="0" marL="0">
+              <a:buNone/>
+            </a:pPr>
+            <a:r>
+              <a:rPr lang="en-US" sz="1400" b="1" spc="300" kern="0" dirty="0">
+                <a:solidFill>
+                  <a:schemeClr val="accent1"/>
+                </a:solidFill>
+              </a:rPr>
+              <a:t>VENDAS ONLINE</a:t>
+            </a:r>
+            <a:endParaRPr lang="en-US" sz="1400" dirty="0"/>
           </a:p>
         </p:txBody>
       </p:sp>
@@ -7251,13 +7767,13 @@
           <p:cNvPr id="3" name="Text 0"/>
           <p:cNvSpPr/>
           <p:nvPr>
-            <p:ph idx="101" type="body" hasCustomPrompt="1"/>
+            <p:ph idx="100" type="title" hasCustomPrompt="1"/>
           </p:nvPr>
         </p:nvSpPr>
         <p:spPr>
           <a:xfrm>
-            <a:off x="731520" y="4160520"/>
-            <a:ext cx="9692640" cy="1188720"/>
+            <a:off x="548640" y="777240"/>
+            <a:ext cx="11064240" cy="822960"/>
           </a:xfrm>
           <a:prstGeom prst="rect">
             <a:avLst/>
@@ -7273,14 +7789,741 @@
               <a:buNone/>
             </a:pPr>
             <a:r>
-              <a:rPr lang="en-US" sz="2200" dirty="0">
-                <a:solidFill>
-                  <a:schemeClr val="accent6"/>
-                </a:solidFill>
-              </a:rPr>
-              <a:t>[2] vendedores · medimos tempo de cotação de motor, cotações por dia e quantas viram pedido. Se não melhorar, paramos.</a:t>
+              <a:rPr lang="en-US" sz="3000" b="1" dirty="0">
+                <a:solidFill>
+                  <a:schemeClr val="tx1"/>
+                </a:solidFill>
+              </a:rPr>
+              <a:t>Um cadastro só, vendendo no site, no Mercado Livre e na Shopee</a:t>
+            </a:r>
+            <a:endParaRPr lang="en-US" sz="3000" dirty="0"/>
+          </a:p>
+        </p:txBody>
+      </p:sp>
+      <p:sp>
+        <p:nvSpPr>
+          <p:cNvPr id="4" name="PartsFlow"/>
+          <p:cNvSpPr/>
+          <p:nvPr/>
+        </p:nvSpPr>
+        <p:spPr>
+          <a:xfrm>
+            <a:off x="548640" y="1783080"/>
+            <a:ext cx="3566160" cy="3566160"/>
+          </a:xfrm>
+          <a:prstGeom prst="roundRect">
+            <a:avLst>
+              <a:gd name="adj" fmla="val 3077"/>
+            </a:avLst>
+          </a:prstGeom>
+          <a:solidFill>
+            <a:srgbClr val="13294B"/>
+          </a:solidFill>
+          <a:ln w="12700">
+            <a:solidFill>
+              <a:srgbClr val="13294B"/>
+            </a:solidFill>
+            <a:prstDash val="solid"/>
+          </a:ln>
+          <a:effectLst>
+            <a:outerShdw sx="100000" sy="100000" kx="0" ky="0" algn="bl" rotWithShape="0" blurRad="76200" dist="25400" dir="5400000">
+              <a:srgbClr val="000000">
+                <a:alpha val="10000"/>
+              </a:srgbClr>
+            </a:outerShdw>
+          </a:effectLst>
+        </p:spPr>
+      </p:sp>
+      <p:sp>
+        <p:nvSpPr>
+          <p:cNvPr id="5" name="Text 3"/>
+          <p:cNvSpPr txBox="1"/>
+          <p:nvPr/>
+        </p:nvSpPr>
+        <p:spPr>
+          <a:xfrm>
+            <a:off x="822960" y="1920240"/>
+            <a:ext cx="3108960" cy="777240"/>
+          </a:xfrm>
+          <a:prstGeom prst="rect">
+            <a:avLst/>
+          </a:prstGeom>
+          <a:noFill/>
+          <a:ln/>
+        </p:spPr>
+        <p:txBody>
+          <a:bodyPr wrap="square" lIns="0" tIns="0" rIns="0" bIns="0" rtlCol="0" anchor="ctr"/>
+          <a:lstStyle/>
+          <a:p>
+            <a:pPr indent="0" marL="0">
+              <a:buNone/>
+            </a:pPr>
+            <a:r>
+              <a:rPr lang="en-US" sz="2200" b="1" dirty="0">
+                <a:solidFill>
+                  <a:srgbClr val="F4F1EA"/>
+                </a:solidFill>
+              </a:rPr>
+              <a:t>PartsFlow</a:t>
             </a:r>
             <a:endParaRPr lang="en-US" sz="2200" dirty="0"/>
+          </a:p>
+          <a:p>
+            <a:pPr indent="0" marL="0">
+              <a:buNone/>
+            </a:pPr>
+            <a:r>
+              <a:rPr lang="en-US" sz="1300" dirty="0">
+                <a:solidFill>
+                  <a:srgbClr val="C9D6E8"/>
+                </a:solidFill>
+              </a:rPr>
+              <a:t>o que já temos:</a:t>
+            </a:r>
+            <a:endParaRPr lang="en-US" sz="2200" dirty="0"/>
+          </a:p>
+        </p:txBody>
+      </p:sp>
+      <p:sp>
+        <p:nvSpPr>
+          <p:cNvPr id="6" name="Text 4"/>
+          <p:cNvSpPr txBox="1"/>
+          <p:nvPr/>
+        </p:nvSpPr>
+        <p:spPr>
+          <a:xfrm>
+            <a:off x="822960" y="2743200"/>
+            <a:ext cx="3108960" cy="2926080"/>
+          </a:xfrm>
+          <a:prstGeom prst="rect">
+            <a:avLst/>
+          </a:prstGeom>
+          <a:noFill/>
+          <a:ln/>
+        </p:spPr>
+        <p:txBody>
+          <a:bodyPr wrap="square" lIns="0" tIns="0" rIns="0" bIns="0" rtlCol="0" anchor="t"/>
+          <a:lstStyle/>
+          <a:p>
+            <a:pPr marL="342900" indent="-342900">
+              <a:spcAft>
+                <a:spcPts val="600"/>
+              </a:spcAft>
+              <a:buSzPct val="100000"/>
+              <a:buChar char="•"/>
+            </a:pPr>
+            <a:r>
+              <a:rPr lang="en-US" sz="1500" dirty="0">
+                <a:solidFill>
+                  <a:srgbClr val="F4F1EA"/>
+                </a:solidFill>
+              </a:rPr>
+              <a:t>Descrição padrão</a:t>
+            </a:r>
+            <a:endParaRPr lang="en-US" sz="1500" dirty="0"/>
+          </a:p>
+          <a:p>
+            <a:pPr marL="342900" indent="-342900">
+              <a:spcAft>
+                <a:spcPts val="600"/>
+              </a:spcAft>
+              <a:buSzPct val="100000"/>
+              <a:buChar char="•"/>
+            </a:pPr>
+            <a:r>
+              <a:rPr lang="en-US" sz="1500" dirty="0">
+                <a:solidFill>
+                  <a:srgbClr val="F4F1EA"/>
+                </a:solidFill>
+              </a:rPr>
+              <a:t>Fotos e desenho</a:t>
+            </a:r>
+            <a:endParaRPr lang="en-US" sz="1500" dirty="0"/>
+          </a:p>
+          <a:p>
+            <a:pPr marL="342900" indent="-342900">
+              <a:spcAft>
+                <a:spcPts val="600"/>
+              </a:spcAft>
+              <a:buSzPct val="100000"/>
+              <a:buChar char="•"/>
+            </a:pPr>
+            <a:r>
+              <a:rPr lang="en-US" sz="1500" dirty="0">
+                <a:solidFill>
+                  <a:srgbClr val="F4F1EA"/>
+                </a:solidFill>
+              </a:rPr>
+              <a:t>Aplicação por veículo</a:t>
+            </a:r>
+            <a:endParaRPr lang="en-US" sz="1500" dirty="0"/>
+          </a:p>
+          <a:p>
+            <a:pPr marL="342900" indent="-342900">
+              <a:spcAft>
+                <a:spcPts val="600"/>
+              </a:spcAft>
+              <a:buSzPct val="100000"/>
+              <a:buChar char="•"/>
+            </a:pPr>
+            <a:r>
+              <a:rPr lang="en-US" sz="1500" dirty="0">
+                <a:solidFill>
+                  <a:srgbClr val="F4F1EA"/>
+                </a:solidFill>
+              </a:rPr>
+              <a:t>Conversões e equivalentes</a:t>
+            </a:r>
+            <a:endParaRPr lang="en-US" sz="1500" dirty="0"/>
+          </a:p>
+          <a:p>
+            <a:pPr marL="342900" indent="-342900">
+              <a:spcAft>
+                <a:spcPts val="600"/>
+              </a:spcAft>
+              <a:buSzPct val="100000"/>
+              <a:buChar char="•"/>
+            </a:pPr>
+            <a:r>
+              <a:rPr lang="en-US" sz="1500" dirty="0">
+                <a:solidFill>
+                  <a:srgbClr val="F4F1EA"/>
+                </a:solidFill>
+              </a:rPr>
+              <a:t>Saldo e preço</a:t>
+            </a:r>
+            <a:endParaRPr lang="en-US" sz="1500" dirty="0"/>
+          </a:p>
+        </p:txBody>
+      </p:sp>
+      <p:sp>
+        <p:nvSpPr>
+          <p:cNvPr id="7" name="Hub"/>
+          <p:cNvSpPr/>
+          <p:nvPr/>
+        </p:nvSpPr>
+        <p:spPr>
+          <a:xfrm>
+            <a:off x="4572000" y="2834640"/>
+            <a:ext cx="2377440" cy="1463040"/>
+          </a:xfrm>
+          <a:prstGeom prst="roundRect">
+            <a:avLst>
+              <a:gd name="adj" fmla="val 7500"/>
+            </a:avLst>
+          </a:prstGeom>
+          <a:solidFill>
+            <a:srgbClr val="E9EEF5"/>
+          </a:solidFill>
+          <a:ln w="12700">
+            <a:solidFill>
+              <a:srgbClr val="E9EEF5"/>
+            </a:solidFill>
+            <a:prstDash val="solid"/>
+          </a:ln>
+          <a:effectLst>
+            <a:outerShdw sx="100000" sy="100000" kx="0" ky="0" algn="bl" rotWithShape="0" blurRad="76200" dist="25400" dir="5400000">
+              <a:srgbClr val="000000">
+                <a:alpha val="10000"/>
+              </a:srgbClr>
+            </a:outerShdw>
+          </a:effectLst>
+        </p:spPr>
+      </p:sp>
+      <p:sp>
+        <p:nvSpPr>
+          <p:cNvPr id="8" name="Text 6"/>
+          <p:cNvSpPr txBox="1"/>
+          <p:nvPr/>
+        </p:nvSpPr>
+        <p:spPr>
+          <a:xfrm>
+            <a:off x="4709160" y="2907792"/>
+            <a:ext cx="2103120" cy="1325880"/>
+          </a:xfrm>
+          <a:prstGeom prst="rect">
+            <a:avLst/>
+          </a:prstGeom>
+          <a:noFill/>
+          <a:ln/>
+        </p:spPr>
+        <p:txBody>
+          <a:bodyPr wrap="square" lIns="0" tIns="0" rIns="0" bIns="0" rtlCol="0" anchor="ctr"/>
+          <a:lstStyle/>
+          <a:p>
+            <a:pPr algn="ctr" indent="0" marL="0">
+              <a:buNone/>
+            </a:pPr>
+            <a:r>
+              <a:rPr lang="en-US" sz="1700" b="1" dirty="0">
+                <a:solidFill>
+                  <a:srgbClr val="13294B"/>
+                </a:solidFill>
+              </a:rPr>
+              <a:t>Integrador</a:t>
+            </a:r>
+            <a:endParaRPr lang="en-US" sz="1700" dirty="0"/>
+          </a:p>
+          <a:p>
+            <a:pPr algn="ctr" indent="0" marL="0">
+              <a:buNone/>
+            </a:pPr>
+            <a:r>
+              <a:rPr lang="en-US" sz="1200" dirty="0">
+                <a:solidFill>
+                  <a:srgbClr val="3E4F66"/>
+                </a:solidFill>
+              </a:rPr>
+              <a:t>hub de marketplace ou API direta</a:t>
+            </a:r>
+            <a:endParaRPr lang="en-US" sz="1700" dirty="0"/>
+          </a:p>
+        </p:txBody>
+      </p:sp>
+      <p:sp>
+        <p:nvSpPr>
+          <p:cNvPr id="9" name="Seta"/>
+          <p:cNvSpPr/>
+          <p:nvPr/>
+        </p:nvSpPr>
+        <p:spPr>
+          <a:xfrm>
+            <a:off x="4160520" y="3364992"/>
+            <a:ext cx="365760" cy="411480"/>
+          </a:xfrm>
+          <a:prstGeom prst="rightArrow">
+            <a:avLst/>
+          </a:prstGeom>
+          <a:solidFill>
+            <a:schemeClr val="accent1"/>
+          </a:solidFill>
+          <a:ln w="12700">
+            <a:solidFill>
+              <a:schemeClr val="accent1"/>
+            </a:solidFill>
+            <a:prstDash val="solid"/>
+          </a:ln>
+        </p:spPr>
+      </p:sp>
+      <p:sp>
+        <p:nvSpPr>
+          <p:cNvPr id="10" name="Seta"/>
+          <p:cNvSpPr/>
+          <p:nvPr/>
+        </p:nvSpPr>
+        <p:spPr>
+          <a:xfrm>
+            <a:off x="6995160" y="3364992"/>
+            <a:ext cx="365760" cy="411480"/>
+          </a:xfrm>
+          <a:prstGeom prst="rightArrow">
+            <a:avLst/>
+          </a:prstGeom>
+          <a:solidFill>
+            <a:schemeClr val="accent1"/>
+          </a:solidFill>
+          <a:ln w="12700">
+            <a:solidFill>
+              <a:schemeClr val="accent1"/>
+            </a:solidFill>
+            <a:prstDash val="solid"/>
+          </a:ln>
+        </p:spPr>
+      </p:sp>
+      <p:sp>
+        <p:nvSpPr>
+          <p:cNvPr id="11" name="Cartão"/>
+          <p:cNvSpPr/>
+          <p:nvPr/>
+        </p:nvSpPr>
+        <p:spPr>
+          <a:xfrm>
+            <a:off x="7452360" y="1783080"/>
+            <a:ext cx="4160520" cy="740664"/>
+          </a:xfrm>
+          <a:prstGeom prst="roundRect">
+            <a:avLst>
+              <a:gd name="adj" fmla="val 14815"/>
+            </a:avLst>
+          </a:prstGeom>
+          <a:solidFill>
+            <a:srgbClr val="E9EEF5"/>
+          </a:solidFill>
+          <a:ln w="12700">
+            <a:solidFill>
+              <a:srgbClr val="E9EEF5"/>
+            </a:solidFill>
+            <a:prstDash val="solid"/>
+          </a:ln>
+          <a:effectLst>
+            <a:outerShdw sx="100000" sy="100000" kx="0" ky="0" algn="bl" rotWithShape="0" blurRad="76200" dist="25400" dir="5400000">
+              <a:srgbClr val="000000">
+                <a:alpha val="10000"/>
+              </a:srgbClr>
+            </a:outerShdw>
+          </a:effectLst>
+        </p:spPr>
+      </p:sp>
+      <p:sp>
+        <p:nvSpPr>
+          <p:cNvPr id="12" name="Text 10"/>
+          <p:cNvSpPr txBox="1"/>
+          <p:nvPr/>
+        </p:nvSpPr>
+        <p:spPr>
+          <a:xfrm>
+            <a:off x="7680960" y="1783080"/>
+            <a:ext cx="3749040" cy="740664"/>
+          </a:xfrm>
+          <a:prstGeom prst="rect">
+            <a:avLst/>
+          </a:prstGeom>
+          <a:noFill/>
+          <a:ln/>
+        </p:spPr>
+        <p:txBody>
+          <a:bodyPr wrap="square" lIns="0" tIns="0" rIns="0" bIns="0" rtlCol="0" anchor="ctr"/>
+          <a:lstStyle/>
+          <a:p>
+            <a:pPr indent="0" marL="0">
+              <a:buNone/>
+            </a:pPr>
+            <a:r>
+              <a:rPr lang="en-US" sz="1700" b="1" dirty="0">
+                <a:solidFill>
+                  <a:srgbClr val="13294B"/>
+                </a:solidFill>
+              </a:rPr>
+              <a:t>Nosso site</a:t>
+            </a:r>
+            <a:endParaRPr lang="en-US" sz="1700" dirty="0"/>
+          </a:p>
+        </p:txBody>
+      </p:sp>
+      <p:sp>
+        <p:nvSpPr>
+          <p:cNvPr id="13" name="Cartão"/>
+          <p:cNvSpPr/>
+          <p:nvPr/>
+        </p:nvSpPr>
+        <p:spPr>
+          <a:xfrm>
+            <a:off x="7452360" y="2724912"/>
+            <a:ext cx="4160520" cy="740664"/>
+          </a:xfrm>
+          <a:prstGeom prst="roundRect">
+            <a:avLst>
+              <a:gd name="adj" fmla="val 14815"/>
+            </a:avLst>
+          </a:prstGeom>
+          <a:solidFill>
+            <a:srgbClr val="E9EEF5"/>
+          </a:solidFill>
+          <a:ln w="12700">
+            <a:solidFill>
+              <a:srgbClr val="E9EEF5"/>
+            </a:solidFill>
+            <a:prstDash val="solid"/>
+          </a:ln>
+          <a:effectLst>
+            <a:outerShdw sx="100000" sy="100000" kx="0" ky="0" algn="bl" rotWithShape="0" blurRad="76200" dist="25400" dir="5400000">
+              <a:srgbClr val="000000">
+                <a:alpha val="10000"/>
+              </a:srgbClr>
+            </a:outerShdw>
+          </a:effectLst>
+        </p:spPr>
+      </p:sp>
+      <p:sp>
+        <p:nvSpPr>
+          <p:cNvPr id="14" name="Text 12"/>
+          <p:cNvSpPr txBox="1"/>
+          <p:nvPr/>
+        </p:nvSpPr>
+        <p:spPr>
+          <a:xfrm>
+            <a:off x="7680960" y="2724912"/>
+            <a:ext cx="3749040" cy="740664"/>
+          </a:xfrm>
+          <a:prstGeom prst="rect">
+            <a:avLst/>
+          </a:prstGeom>
+          <a:noFill/>
+          <a:ln/>
+        </p:spPr>
+        <p:txBody>
+          <a:bodyPr wrap="square" lIns="0" tIns="0" rIns="0" bIns="0" rtlCol="0" anchor="ctr"/>
+          <a:lstStyle/>
+          <a:p>
+            <a:pPr indent="0" marL="0">
+              <a:buNone/>
+            </a:pPr>
+            <a:r>
+              <a:rPr lang="en-US" sz="1700" b="1" dirty="0">
+                <a:solidFill>
+                  <a:srgbClr val="13294B"/>
+                </a:solidFill>
+              </a:rPr>
+              <a:t>Mercado Livre</a:t>
+            </a:r>
+            <a:endParaRPr lang="en-US" sz="1700" dirty="0"/>
+          </a:p>
+        </p:txBody>
+      </p:sp>
+      <p:sp>
+        <p:nvSpPr>
+          <p:cNvPr id="15" name="Cartão"/>
+          <p:cNvSpPr/>
+          <p:nvPr/>
+        </p:nvSpPr>
+        <p:spPr>
+          <a:xfrm>
+            <a:off x="7452360" y="3666744"/>
+            <a:ext cx="4160520" cy="740664"/>
+          </a:xfrm>
+          <a:prstGeom prst="roundRect">
+            <a:avLst>
+              <a:gd name="adj" fmla="val 14815"/>
+            </a:avLst>
+          </a:prstGeom>
+          <a:solidFill>
+            <a:srgbClr val="E9EEF5"/>
+          </a:solidFill>
+          <a:ln w="12700">
+            <a:solidFill>
+              <a:srgbClr val="E9EEF5"/>
+            </a:solidFill>
+            <a:prstDash val="solid"/>
+          </a:ln>
+          <a:effectLst>
+            <a:outerShdw sx="100000" sy="100000" kx="0" ky="0" algn="bl" rotWithShape="0" blurRad="76200" dist="25400" dir="5400000">
+              <a:srgbClr val="000000">
+                <a:alpha val="10000"/>
+              </a:srgbClr>
+            </a:outerShdw>
+          </a:effectLst>
+        </p:spPr>
+      </p:sp>
+      <p:sp>
+        <p:nvSpPr>
+          <p:cNvPr id="16" name="Text 14"/>
+          <p:cNvSpPr txBox="1"/>
+          <p:nvPr/>
+        </p:nvSpPr>
+        <p:spPr>
+          <a:xfrm>
+            <a:off x="7680960" y="3666744"/>
+            <a:ext cx="3749040" cy="740664"/>
+          </a:xfrm>
+          <a:prstGeom prst="rect">
+            <a:avLst/>
+          </a:prstGeom>
+          <a:noFill/>
+          <a:ln/>
+        </p:spPr>
+        <p:txBody>
+          <a:bodyPr wrap="square" lIns="0" tIns="0" rIns="0" bIns="0" rtlCol="0" anchor="ctr"/>
+          <a:lstStyle/>
+          <a:p>
+            <a:pPr indent="0" marL="0">
+              <a:buNone/>
+            </a:pPr>
+            <a:r>
+              <a:rPr lang="en-US" sz="1700" b="1" dirty="0">
+                <a:solidFill>
+                  <a:srgbClr val="13294B"/>
+                </a:solidFill>
+              </a:rPr>
+              <a:t>Shopee</a:t>
+            </a:r>
+            <a:endParaRPr lang="en-US" sz="1700" dirty="0"/>
+          </a:p>
+        </p:txBody>
+      </p:sp>
+      <p:sp>
+        <p:nvSpPr>
+          <p:cNvPr id="17" name="Cartão"/>
+          <p:cNvSpPr/>
+          <p:nvPr/>
+        </p:nvSpPr>
+        <p:spPr>
+          <a:xfrm>
+            <a:off x="7452360" y="4608576"/>
+            <a:ext cx="4160520" cy="740664"/>
+          </a:xfrm>
+          <a:prstGeom prst="roundRect">
+            <a:avLst>
+              <a:gd name="adj" fmla="val 14815"/>
+            </a:avLst>
+          </a:prstGeom>
+          <a:solidFill>
+            <a:srgbClr val="E9EEF5"/>
+          </a:solidFill>
+          <a:ln w="12700">
+            <a:solidFill>
+              <a:srgbClr val="E9EEF5"/>
+            </a:solidFill>
+            <a:prstDash val="solid"/>
+          </a:ln>
+          <a:effectLst>
+            <a:outerShdw sx="100000" sy="100000" kx="0" ky="0" algn="bl" rotWithShape="0" blurRad="76200" dist="25400" dir="5400000">
+              <a:srgbClr val="000000">
+                <a:alpha val="10000"/>
+              </a:srgbClr>
+            </a:outerShdw>
+          </a:effectLst>
+        </p:spPr>
+      </p:sp>
+      <p:sp>
+        <p:nvSpPr>
+          <p:cNvPr id="18" name="Text 16"/>
+          <p:cNvSpPr txBox="1"/>
+          <p:nvPr/>
+        </p:nvSpPr>
+        <p:spPr>
+          <a:xfrm>
+            <a:off x="7680960" y="4608576"/>
+            <a:ext cx="3749040" cy="740664"/>
+          </a:xfrm>
+          <a:prstGeom prst="rect">
+            <a:avLst/>
+          </a:prstGeom>
+          <a:noFill/>
+          <a:ln/>
+        </p:spPr>
+        <p:txBody>
+          <a:bodyPr wrap="square" lIns="0" tIns="0" rIns="0" bIns="0" rtlCol="0" anchor="ctr"/>
+          <a:lstStyle/>
+          <a:p>
+            <a:pPr indent="0" marL="0">
+              <a:buNone/>
+            </a:pPr>
+            <a:r>
+              <a:rPr lang="en-US" sz="1700" b="1" dirty="0">
+                <a:solidFill>
+                  <a:srgbClr val="13294B"/>
+                </a:solidFill>
+              </a:rPr>
+              <a:t>Outros (Amazon, Magalu…)</a:t>
+            </a:r>
+            <a:endParaRPr lang="en-US" sz="1700" dirty="0"/>
+          </a:p>
+        </p:txBody>
+      </p:sp>
+      <p:sp>
+        <p:nvSpPr>
+          <p:cNvPr id="19" name="Text 17"/>
+          <p:cNvSpPr txBox="1"/>
+          <p:nvPr/>
+        </p:nvSpPr>
+        <p:spPr>
+          <a:xfrm>
+            <a:off x="548640" y="5577840"/>
+            <a:ext cx="11064240" cy="640080"/>
+          </a:xfrm>
+          <a:prstGeom prst="rect">
+            <a:avLst/>
+          </a:prstGeom>
+          <a:noFill/>
+          <a:ln/>
+        </p:spPr>
+        <p:txBody>
+          <a:bodyPr wrap="square" lIns="0" tIns="0" rIns="0" bIns="0" rtlCol="0" anchor="ctr"/>
+          <a:lstStyle/>
+          <a:p>
+            <a:pPr indent="0" marL="0">
+              <a:buNone/>
+            </a:pPr>
+            <a:r>
+              <a:rPr lang="en-US" sz="1400" b="1" dirty="0">
+                <a:solidFill>
+                  <a:srgbClr val="C2591F"/>
+                </a:solidFill>
+              </a:rPr>
+              <a:t>→ vai: </a:t>
+            </a:r>
+            <a:pPr indent="0" marL="0">
+              <a:buNone/>
+            </a:pPr>
+            <a:r>
+              <a:rPr lang="en-US" sz="1400" dirty="0">
+                <a:solidFill>
+                  <a:srgbClr val="3E4F66"/>
+                </a:solidFill>
+              </a:rPr>
+              <a:t>anúncio com foto, descrição e compatibilidade de veículo · saldo e preço atualizados sozinhos</a:t>
+            </a:r>
+            <a:endParaRPr lang="en-US" sz="1400" dirty="0"/>
+          </a:p>
+          <a:p>
+            <a:pPr indent="0" marL="0">
+              <a:buNone/>
+            </a:pPr>
+            <a:r>
+              <a:rPr lang="en-US" sz="1400" b="1" dirty="0">
+                <a:solidFill>
+                  <a:srgbClr val="1E8449"/>
+                </a:solidFill>
+              </a:rPr>
+              <a:t>← volta: </a:t>
+            </a:r>
+            <a:pPr indent="0" marL="0">
+              <a:buNone/>
+            </a:pPr>
+            <a:r>
+              <a:rPr lang="en-US" sz="1400" dirty="0">
+                <a:solidFill>
+                  <a:srgbClr val="3E4F66"/>
+                </a:solidFill>
+              </a:rPr>
+              <a:t>pedidos e perguntas entram no PartsFlow e seguem pro ERP</a:t>
+            </a:r>
+            <a:endParaRPr lang="en-US" sz="1400" dirty="0"/>
+          </a:p>
+        </p:txBody>
+      </p:sp>
+      <p:sp>
+        <p:nvSpPr>
+          <p:cNvPr id="25" name="Slide Number Placeholder 0"/>
+          <p:cNvSpPr>
+            <a:spLocks noGrp="1"/>
+          </p:cNvSpPr>
+          <p:nvPr>
+            <p:ph type="sldNum" sz="quarter" idx="4294967295"/>
+          </p:nvPr>
+        </p:nvSpPr>
+        <p:spPr>
+          <a:xfrm>
+            <a:off x="11064240" y="6382512"/>
+            <a:ext cx="640080" cy="274320"/>
+          </a:xfrm>
+          <a:prstGeom prst="rect">
+            <a:avLst/>
+          </a:prstGeom>
+          <a:extLst>
+            <a:ext uri="{C572A759-6A51-4108-AA02-DFA0A04FC94B}">
+              <ma14:wrappingTextBoxFlag xmlns:ma14="http://schemas.microsoft.com/office/mac/drawingml/2011/main" val="0"/>
+            </a:ext>
+          </a:extLst>
+        </p:spPr>
+        <p:txBody>
+          <a:bodyPr/>
+          <a:lstStyle>
+            <a:lvl1pPr>
+              <a:defRPr sz="1100">
+                <a:solidFill>
+                  <a:srgbClr val="6B7A90"/>
+                </a:solidFill>
+              </a:defRPr>
+            </a:lvl1pPr>
+          </a:lstStyle>
+          <a:p>
+            <a:pPr algn="r"/>
+            <a:fld id="{F7021451-1387-4CA6-816F-3879F97B5CBC}" type="slidenum">
+              <a:rPr b="0" lang="en-US"/>
+              <a:t>9</a:t>
+            </a:fld>
+            <a:endParaRPr lang="en-US"/>
           </a:p>
         </p:txBody>
       </p:sp>

</xml_diff>